<commit_message>
re-build site; Lecture 09 stuff
</commit_message>
<xml_diff>
--- a/docs/lectures/DeepQuestions.pptx
+++ b/docs/lectures/DeepQuestions.pptx
@@ -5,24 +5,27 @@
     <p:sldMasterId id="2147483660" r:id="rId1"/>
   </p:sldMasterIdLst>
   <p:handoutMasterIdLst>
-    <p:handoutMasterId r:id="rId17"/>
+    <p:handoutMasterId r:id="rId20"/>
   </p:handoutMasterIdLst>
   <p:sldIdLst>
-    <p:sldId id="256" r:id="rId2"/>
-    <p:sldId id="257" r:id="rId3"/>
-    <p:sldId id="258" r:id="rId4"/>
-    <p:sldId id="259" r:id="rId5"/>
-    <p:sldId id="260" r:id="rId6"/>
-    <p:sldId id="261" r:id="rId7"/>
-    <p:sldId id="262" r:id="rId8"/>
-    <p:sldId id="264" r:id="rId9"/>
-    <p:sldId id="263" r:id="rId10"/>
-    <p:sldId id="265" r:id="rId11"/>
-    <p:sldId id="268" r:id="rId12"/>
-    <p:sldId id="266" r:id="rId13"/>
-    <p:sldId id="267" r:id="rId14"/>
-    <p:sldId id="269" r:id="rId15"/>
-    <p:sldId id="270" r:id="rId16"/>
+    <p:sldId id="257" r:id="rId2"/>
+    <p:sldId id="271" r:id="rId3"/>
+    <p:sldId id="272" r:id="rId4"/>
+    <p:sldId id="258" r:id="rId5"/>
+    <p:sldId id="259" r:id="rId6"/>
+    <p:sldId id="260" r:id="rId7"/>
+    <p:sldId id="261" r:id="rId8"/>
+    <p:sldId id="262" r:id="rId9"/>
+    <p:sldId id="264" r:id="rId10"/>
+    <p:sldId id="263" r:id="rId11"/>
+    <p:sldId id="265" r:id="rId12"/>
+    <p:sldId id="268" r:id="rId13"/>
+    <p:sldId id="266" r:id="rId14"/>
+    <p:sldId id="273" r:id="rId15"/>
+    <p:sldId id="274" r:id="rId16"/>
+    <p:sldId id="267" r:id="rId17"/>
+    <p:sldId id="269" r:id="rId18"/>
+    <p:sldId id="270" r:id="rId19"/>
   </p:sldIdLst>
   <p:sldSz cx="9144000" cy="6858000" type="screen4x3"/>
   <p:notesSz cx="6858000" cy="9144000"/>
@@ -236,7 +239,7 @@
           <a:p>
             <a:fld id="{08BD4FA9-F3CE-45B3-A980-C331C6F1EF65}" type="datetimeFigureOut">
               <a:rPr lang="en-US" smtClean="0"/>
-              <a:t>2/28/2023</a:t>
+              <a:t>2/26/2026</a:t>
             </a:fld>
             <a:endParaRPr lang="en-US"/>
           </a:p>
@@ -509,7 +512,7 @@
           <a:p>
             <a:fld id="{EAAD3657-2200-4D14-82C0-10C39B0F0F06}" type="datetime1">
               <a:rPr lang="en-US" smtClean="0"/>
-              <a:t>2/28/2023</a:t>
+              <a:t>2/26/2026</a:t>
             </a:fld>
             <a:endParaRPr lang="en-US"/>
           </a:p>
@@ -677,7 +680,7 @@
           <a:p>
             <a:fld id="{11BBAF55-A85E-4993-914E-FC1E5AA7DF24}" type="datetime1">
               <a:rPr lang="en-US" smtClean="0"/>
-              <a:t>2/28/2023</a:t>
+              <a:t>2/26/2026</a:t>
             </a:fld>
             <a:endParaRPr lang="en-US"/>
           </a:p>
@@ -855,7 +858,7 @@
           <a:p>
             <a:fld id="{39816E07-E1DB-44A4-A5E5-9F4B54E8C933}" type="datetime1">
               <a:rPr lang="en-US" smtClean="0"/>
-              <a:t>2/28/2023</a:t>
+              <a:t>2/26/2026</a:t>
             </a:fld>
             <a:endParaRPr lang="en-US"/>
           </a:p>
@@ -1040,7 +1043,7 @@
           <a:p>
             <a:fld id="{C2B1AD17-B813-4477-8AFE-B1860CC59113}" type="datetime1">
               <a:rPr lang="en-US" smtClean="0"/>
-              <a:t>2/28/2023</a:t>
+              <a:t>2/26/2026</a:t>
             </a:fld>
             <a:endParaRPr lang="en-US"/>
           </a:p>
@@ -1285,7 +1288,7 @@
           <a:p>
             <a:fld id="{D0975C0D-5C9E-48CC-8D31-F42D19FA8F7A}" type="datetime1">
               <a:rPr lang="en-US" smtClean="0"/>
-              <a:t>2/28/2023</a:t>
+              <a:t>2/26/2026</a:t>
             </a:fld>
             <a:endParaRPr lang="en-US"/>
           </a:p>
@@ -1570,7 +1573,7 @@
           <a:p>
             <a:fld id="{28657551-0F2B-4F09-86FD-F7994CE83DC5}" type="datetime1">
               <a:rPr lang="en-US" smtClean="0"/>
-              <a:t>2/28/2023</a:t>
+              <a:t>2/26/2026</a:t>
             </a:fld>
             <a:endParaRPr lang="en-US"/>
           </a:p>
@@ -1989,7 +1992,7 @@
           <a:p>
             <a:fld id="{3929D2B2-4200-46B9-96C3-02A55D5FAA00}" type="datetime1">
               <a:rPr lang="en-US" smtClean="0"/>
-              <a:t>2/28/2023</a:t>
+              <a:t>2/26/2026</a:t>
             </a:fld>
             <a:endParaRPr lang="en-US"/>
           </a:p>
@@ -2106,7 +2109,7 @@
           <a:p>
             <a:fld id="{41FF7722-74E8-497F-A072-89677A2C2373}" type="datetime1">
               <a:rPr lang="en-US" smtClean="0"/>
-              <a:t>2/28/2023</a:t>
+              <a:t>2/26/2026</a:t>
             </a:fld>
             <a:endParaRPr lang="en-US"/>
           </a:p>
@@ -2201,7 +2204,7 @@
           <a:p>
             <a:fld id="{BD26212E-B46B-426F-AE59-AA326827D9E0}" type="datetime1">
               <a:rPr lang="en-US" smtClean="0"/>
-              <a:t>2/28/2023</a:t>
+              <a:t>2/26/2026</a:t>
             </a:fld>
             <a:endParaRPr lang="en-US"/>
           </a:p>
@@ -2476,7 +2479,7 @@
           <a:p>
             <a:fld id="{FB9B81E8-09EA-4684-A39F-38DE1E49D20C}" type="datetime1">
               <a:rPr lang="en-US" smtClean="0"/>
-              <a:t>2/28/2023</a:t>
+              <a:t>2/26/2026</a:t>
             </a:fld>
             <a:endParaRPr lang="en-US"/>
           </a:p>
@@ -2728,7 +2731,7 @@
           <a:p>
             <a:fld id="{35C5CC5F-056C-4047-9A5C-9F5B4BED129B}" type="datetime1">
               <a:rPr lang="en-US" smtClean="0"/>
-              <a:t>2/28/2023</a:t>
+              <a:t>2/26/2026</a:t>
             </a:fld>
             <a:endParaRPr lang="en-US"/>
           </a:p>
@@ -2942,7 +2945,7 @@
           <a:p>
             <a:fld id="{E8171053-07BD-4A17-AC24-0A22EAA36098}" type="datetime1">
               <a:rPr lang="en-US" smtClean="0"/>
-              <a:t>2/28/2023</a:t>
+              <a:t>2/26/2026</a:t>
             </a:fld>
             <a:endParaRPr lang="en-US"/>
           </a:p>
@@ -3320,7 +3323,7 @@
           </a:blip>
           <a:srcRect/>
           <a:stretch>
-            <a:fillRect l="-4000" r="-4000"/>
+            <a:fillRect/>
           </a:stretch>
         </a:blipFill>
         <a:effectLst/>
@@ -3342,92 +3345,85 @@
       </p:grpSpPr>
       <p:sp>
         <p:nvSpPr>
-          <p:cNvPr id="2" name="Title 1"/>
+          <p:cNvPr id="2" name="Slide Number Placeholder 1"/>
           <p:cNvSpPr>
             <a:spLocks noGrp="1"/>
           </p:cNvSpPr>
           <p:nvPr>
-            <p:ph type="ctrTitle"/>
+            <p:ph type="sldNum" sz="quarter" idx="12"/>
           </p:nvPr>
         </p:nvSpPr>
+        <p:spPr/>
+        <p:txBody>
+          <a:bodyPr/>
+          <a:lstStyle/>
+          <a:p>
+            <a:fld id="{621225AB-15B9-4C79-A121-04D1DC7E2307}" type="slidenum">
+              <a:rPr lang="en-US" smtClean="0"/>
+              <a:t>1</a:t>
+            </a:fld>
+            <a:endParaRPr lang="en-US"/>
+          </a:p>
+        </p:txBody>
+      </p:sp>
+      <p:sp>
+        <p:nvSpPr>
+          <p:cNvPr id="4" name="TextBox 3"/>
+          <p:cNvSpPr txBox="1"/>
+          <p:nvPr/>
+        </p:nvSpPr>
         <p:spPr>
           <a:xfrm>
-            <a:off x="685800" y="2667000"/>
-            <a:ext cx="7772400" cy="1470025"/>
-          </a:xfrm>
+            <a:off x="762000" y="2046233"/>
+            <a:ext cx="7162800" cy="1754326"/>
+          </a:xfrm>
+          <a:prstGeom prst="rect">
+            <a:avLst/>
+          </a:prstGeom>
           <a:noFill/>
         </p:spPr>
         <p:txBody>
-          <a:bodyPr>
-            <a:noAutofit/>
+          <a:bodyPr wrap="square" rtlCol="0">
+            <a:spAutoFit/>
           </a:bodyPr>
           <a:lstStyle/>
           <a:p>
-            <a:r>
-              <a:rPr lang="en-US" sz="4800" b="1" dirty="0"/>
-              <a:t>Deep Questions of Data Visualization</a:t>
-            </a:r>
-          </a:p>
-        </p:txBody>
-      </p:sp>
-      <p:sp>
-        <p:nvSpPr>
-          <p:cNvPr id="3" name="Subtitle 2"/>
-          <p:cNvSpPr>
-            <a:spLocks noGrp="1"/>
-          </p:cNvSpPr>
-          <p:nvPr>
-            <p:ph type="subTitle" idx="1"/>
-          </p:nvPr>
-        </p:nvSpPr>
-        <p:spPr>
-          <a:xfrm>
-            <a:off x="1371600" y="4648200"/>
-            <a:ext cx="6400800" cy="1752600"/>
-          </a:xfrm>
-        </p:spPr>
-        <p:txBody>
-          <a:bodyPr/>
-          <a:lstStyle/>
-          <a:p>
-            <a:r>
-              <a:rPr lang="en-US" dirty="0">
+            <a:pPr algn="ctr"/>
+            <a:r>
+              <a:rPr lang="en-CA" sz="5400" b="1" dirty="0">
                 <a:solidFill>
                   <a:schemeClr val="bg1"/>
                 </a:solidFill>
               </a:rPr>
-              <a:t>Michael Friendly</a:t>
-            </a:r>
-          </a:p>
-          <a:p>
-            <a:endParaRPr lang="en-US" dirty="0"/>
+              <a:t>Deep Questions of Data Visualization</a:t>
+            </a:r>
           </a:p>
         </p:txBody>
       </p:sp>
       <p:pic>
         <p:nvPicPr>
-          <p:cNvPr id="4" name="Picture 3"/>
+          <p:cNvPr id="6" name="Picture 5">
+            <a:extLst>
+              <a:ext uri="{FF2B5EF4-FFF2-40B4-BE49-F238E27FC236}">
+                <a16:creationId xmlns:a16="http://schemas.microsoft.com/office/drawing/2014/main" id="{8D4738BC-C316-C6E3-C8F7-330A787C2856}"/>
+              </a:ext>
+            </a:extLst>
+          </p:cNvPr>
           <p:cNvPicPr>
             <a:picLocks noChangeAspect="1"/>
           </p:cNvPicPr>
           <p:nvPr/>
         </p:nvPicPr>
         <p:blipFill>
-          <a:blip r:embed="rId3">
-            <a:extLst>
-              <a:ext uri="{28A0092B-C50C-407E-A947-70E740481C1C}">
-                <a14:useLocalDpi xmlns:a14="http://schemas.microsoft.com/office/drawing/2010/main" val="0"/>
-              </a:ext>
-            </a:extLst>
-          </a:blip>
+          <a:blip r:embed="rId3"/>
           <a:stretch>
             <a:fillRect/>
           </a:stretch>
         </p:blipFill>
         <p:spPr>
           <a:xfrm>
-            <a:off x="1813128" y="152400"/>
-            <a:ext cx="2304138" cy="2340000"/>
+            <a:off x="762000" y="4347617"/>
+            <a:ext cx="1234547" cy="1585097"/>
           </a:xfrm>
           <a:prstGeom prst="rect">
             <a:avLst/>
@@ -3436,7 +3432,13 @@
       </p:pic>
       <p:pic>
         <p:nvPicPr>
-          <p:cNvPr id="5" name="Picture 4"/>
+          <p:cNvPr id="5" name="Picture 4">
+            <a:extLst>
+              <a:ext uri="{FF2B5EF4-FFF2-40B4-BE49-F238E27FC236}">
+                <a16:creationId xmlns:a16="http://schemas.microsoft.com/office/drawing/2014/main" id="{EBEE41DE-B06D-976C-AF04-3C7D2589E767}"/>
+              </a:ext>
+            </a:extLst>
+          </p:cNvPr>
           <p:cNvPicPr>
             <a:picLocks noChangeAspect="1"/>
           </p:cNvPicPr>
@@ -3456,8 +3458,8 @@
         </p:blipFill>
         <p:spPr>
           <a:xfrm>
-            <a:off x="5257800" y="228600"/>
-            <a:ext cx="2138071" cy="2340000"/>
+            <a:off x="990600" y="212486"/>
+            <a:ext cx="1600200" cy="1625105"/>
           </a:xfrm>
           <a:prstGeom prst="rect">
             <a:avLst/>
@@ -3466,10 +3468,10 @@
       </p:pic>
       <p:pic>
         <p:nvPicPr>
-          <p:cNvPr id="7" name="Picture 6" descr="A picture containing text&#10;&#10;Description automatically generated">
+          <p:cNvPr id="7" name="Picture 6">
             <a:extLst>
               <a:ext uri="{FF2B5EF4-FFF2-40B4-BE49-F238E27FC236}">
-                <a16:creationId xmlns:a16="http://schemas.microsoft.com/office/drawing/2014/main" id="{03565028-56F1-D3CE-DE4E-454C1A9B5900}"/>
+                <a16:creationId xmlns:a16="http://schemas.microsoft.com/office/drawing/2014/main" id="{3CD7C19B-AC6A-4498-C067-FAEE90A7F021}"/>
               </a:ext>
             </a:extLst>
           </p:cNvPr>
@@ -3492,8 +3494,8 @@
         </p:blipFill>
         <p:spPr>
           <a:xfrm>
-            <a:off x="7848600" y="2819400"/>
-            <a:ext cx="1219200" cy="1219200"/>
+            <a:off x="3620866" y="222317"/>
+            <a:ext cx="1524000" cy="1667933"/>
           </a:xfrm>
           <a:prstGeom prst="rect">
             <a:avLst/>
@@ -3502,10 +3504,10 @@
       </p:pic>
       <p:pic>
         <p:nvPicPr>
-          <p:cNvPr id="10" name="Picture 9" descr="A picture containing text&#10;&#10;Description automatically generated">
+          <p:cNvPr id="11" name="Picture 10" descr="A black and white panda&#10;&#10;Description automatically generated with low confidence">
             <a:extLst>
               <a:ext uri="{FF2B5EF4-FFF2-40B4-BE49-F238E27FC236}">
-                <a16:creationId xmlns:a16="http://schemas.microsoft.com/office/drawing/2014/main" id="{9F8EC9F1-5A9B-F656-EDBD-FA784CC865CD}"/>
+                <a16:creationId xmlns:a16="http://schemas.microsoft.com/office/drawing/2014/main" id="{29B5370A-A17F-D370-73AD-14AAC402AB46}"/>
               </a:ext>
             </a:extLst>
           </p:cNvPr>
@@ -3515,7 +3517,7 @@
           <p:nvPr/>
         </p:nvPicPr>
         <p:blipFill>
-          <a:blip r:embed="rId5">
+          <a:blip r:embed="rId6" cstate="print">
             <a:extLst>
               <a:ext uri="{28A0092B-C50C-407E-A947-70E740481C1C}">
                 <a14:useLocalDpi xmlns:a14="http://schemas.microsoft.com/office/drawing/2010/main" val="0"/>
@@ -3528,56 +3530,20 @@
         </p:blipFill>
         <p:spPr>
           <a:xfrm>
-            <a:off x="4191000" y="228600"/>
-            <a:ext cx="1219200" cy="1219200"/>
+            <a:off x="2743200" y="5932714"/>
+            <a:ext cx="915152" cy="610437"/>
           </a:xfrm>
           <a:prstGeom prst="rect">
             <a:avLst/>
           </a:prstGeom>
         </p:spPr>
       </p:pic>
-      <p:sp>
-        <p:nvSpPr>
-          <p:cNvPr id="6" name="TextBox 5">
+      <p:pic>
+        <p:nvPicPr>
+          <p:cNvPr id="12" name="Picture 11" descr="A picture containing text&#10;&#10;Description automatically generated">
             <a:extLst>
               <a:ext uri="{FF2B5EF4-FFF2-40B4-BE49-F238E27FC236}">
-                <a16:creationId xmlns:a16="http://schemas.microsoft.com/office/drawing/2014/main" id="{FD5C3D65-E304-286A-9858-84F79B088641}"/>
-              </a:ext>
-            </a:extLst>
-          </p:cNvPr>
-          <p:cNvSpPr txBox="1"/>
-          <p:nvPr/>
-        </p:nvSpPr>
-        <p:spPr>
-          <a:xfrm>
-            <a:off x="4305300" y="1318667"/>
-            <a:ext cx="838200" cy="769441"/>
-          </a:xfrm>
-          <a:prstGeom prst="rect">
-            <a:avLst/>
-          </a:prstGeom>
-          <a:noFill/>
-        </p:spPr>
-        <p:txBody>
-          <a:bodyPr wrap="square" rtlCol="0">
-            <a:spAutoFit/>
-          </a:bodyPr>
-          <a:lstStyle/>
-          <a:p>
-            <a:pPr algn="ctr"/>
-            <a:r>
-              <a:rPr lang="en-CA" sz="4400" dirty="0"/>
-              <a:t>??</a:t>
-            </a:r>
-          </a:p>
-        </p:txBody>
-      </p:sp>
-      <p:pic>
-        <p:nvPicPr>
-          <p:cNvPr id="8" name="Picture 7" descr="A picture containing text&#10;&#10;Description automatically generated">
-            <a:extLst>
-              <a:ext uri="{FF2B5EF4-FFF2-40B4-BE49-F238E27FC236}">
-                <a16:creationId xmlns:a16="http://schemas.microsoft.com/office/drawing/2014/main" id="{7CE90214-92C1-E322-E0A2-5CF38132BD6E}"/>
+                <a16:creationId xmlns:a16="http://schemas.microsoft.com/office/drawing/2014/main" id="{B59CA975-0BA4-88E0-B85B-88DC45DAABD7}"/>
               </a:ext>
             </a:extLst>
           </p:cNvPr>
@@ -3587,7 +3553,7 @@
           <p:nvPr/>
         </p:nvPicPr>
         <p:blipFill>
-          <a:blip r:embed="rId5">
+          <a:blip r:embed="rId7">
             <a:extLst>
               <a:ext uri="{28A0092B-C50C-407E-A947-70E740481C1C}">
                 <a14:useLocalDpi xmlns:a14="http://schemas.microsoft.com/office/drawing/2010/main" val="0"/>
@@ -3600,8 +3566,345 @@
         </p:blipFill>
         <p:spPr>
           <a:xfrm>
-            <a:off x="1447800" y="5198961"/>
+            <a:off x="6858000" y="3920965"/>
             <a:ext cx="1219200" cy="1219200"/>
+          </a:xfrm>
+          <a:prstGeom prst="rect">
+            <a:avLst/>
+          </a:prstGeom>
+        </p:spPr>
+      </p:pic>
+      <p:sp>
+        <p:nvSpPr>
+          <p:cNvPr id="13" name="TextBox 12">
+            <a:extLst>
+              <a:ext uri="{FF2B5EF4-FFF2-40B4-BE49-F238E27FC236}">
+                <a16:creationId xmlns:a16="http://schemas.microsoft.com/office/drawing/2014/main" id="{1509B4BC-4CBA-A45C-A1EC-35D7723399D3}"/>
+              </a:ext>
+            </a:extLst>
+          </p:cNvPr>
+          <p:cNvSpPr txBox="1"/>
+          <p:nvPr/>
+        </p:nvSpPr>
+        <p:spPr>
+          <a:xfrm>
+            <a:off x="2696565" y="635801"/>
+            <a:ext cx="838200" cy="830997"/>
+          </a:xfrm>
+          <a:prstGeom prst="rect">
+            <a:avLst/>
+          </a:prstGeom>
+          <a:noFill/>
+        </p:spPr>
+        <p:txBody>
+          <a:bodyPr wrap="square" rtlCol="0">
+            <a:spAutoFit/>
+          </a:bodyPr>
+          <a:lstStyle/>
+          <a:p>
+            <a:pPr algn="ctr"/>
+            <a:r>
+              <a:rPr lang="en-CA" sz="4800" b="1" dirty="0">
+                <a:solidFill>
+                  <a:schemeClr val="bg1"/>
+                </a:solidFill>
+              </a:rPr>
+              <a:t>??</a:t>
+            </a:r>
+          </a:p>
+        </p:txBody>
+      </p:sp>
+      <p:sp>
+        <p:nvSpPr>
+          <p:cNvPr id="14" name="TextBox 13">
+            <a:extLst>
+              <a:ext uri="{FF2B5EF4-FFF2-40B4-BE49-F238E27FC236}">
+                <a16:creationId xmlns:a16="http://schemas.microsoft.com/office/drawing/2014/main" id="{C1200BBC-CD1F-A0FB-5C04-C87EBFBF67CE}"/>
+              </a:ext>
+            </a:extLst>
+          </p:cNvPr>
+          <p:cNvSpPr txBox="1"/>
+          <p:nvPr/>
+        </p:nvSpPr>
+        <p:spPr>
+          <a:xfrm>
+            <a:off x="5238136" y="635801"/>
+            <a:ext cx="838200" cy="830997"/>
+          </a:xfrm>
+          <a:prstGeom prst="rect">
+            <a:avLst/>
+          </a:prstGeom>
+          <a:noFill/>
+        </p:spPr>
+        <p:txBody>
+          <a:bodyPr wrap="square" rtlCol="0">
+            <a:spAutoFit/>
+          </a:bodyPr>
+          <a:lstStyle/>
+          <a:p>
+            <a:pPr algn="ctr"/>
+            <a:r>
+              <a:rPr lang="en-CA" sz="4800" b="1" dirty="0">
+                <a:solidFill>
+                  <a:schemeClr val="bg1"/>
+                </a:solidFill>
+              </a:rPr>
+              <a:t>??</a:t>
+            </a:r>
+          </a:p>
+        </p:txBody>
+      </p:sp>
+      <p:sp>
+        <p:nvSpPr>
+          <p:cNvPr id="15" name="Subtitle 2">
+            <a:extLst>
+              <a:ext uri="{FF2B5EF4-FFF2-40B4-BE49-F238E27FC236}">
+                <a16:creationId xmlns:a16="http://schemas.microsoft.com/office/drawing/2014/main" id="{6F38771F-E331-3DFA-13D1-A6EAAD49353A}"/>
+              </a:ext>
+            </a:extLst>
+          </p:cNvPr>
+          <p:cNvSpPr txBox="1">
+            <a:spLocks/>
+          </p:cNvSpPr>
+          <p:nvPr/>
+        </p:nvSpPr>
+        <p:spPr>
+          <a:xfrm>
+            <a:off x="2590800" y="4347617"/>
+            <a:ext cx="6400800" cy="1752600"/>
+          </a:xfrm>
+          <a:prstGeom prst="rect">
+            <a:avLst/>
+          </a:prstGeom>
+        </p:spPr>
+        <p:txBody>
+          <a:bodyPr/>
+          <a:lstStyle>
+            <a:lvl1pPr marL="342900" indent="-342900" algn="l" defTabSz="914400" rtl="0" eaLnBrk="1" latinLnBrk="0" hangingPunct="1">
+              <a:spcBef>
+                <a:spcPct val="20000"/>
+              </a:spcBef>
+              <a:buClr>
+                <a:srgbClr val="0070C0"/>
+              </a:buClr>
+              <a:buSzPct val="115000"/>
+              <a:buFont typeface="Arial" panose="020B0604020202020204" pitchFamily="34" charset="0"/>
+              <a:buChar char="•"/>
+              <a:defRPr sz="3200" kern="1200">
+                <a:solidFill>
+                  <a:schemeClr val="tx1"/>
+                </a:solidFill>
+                <a:latin typeface="+mn-lt"/>
+                <a:ea typeface="+mn-ea"/>
+                <a:cs typeface="+mn-cs"/>
+              </a:defRPr>
+            </a:lvl1pPr>
+            <a:lvl2pPr marL="742950" indent="-285750" algn="l" defTabSz="914400" rtl="0" eaLnBrk="1" latinLnBrk="0" hangingPunct="1">
+              <a:spcBef>
+                <a:spcPct val="20000"/>
+              </a:spcBef>
+              <a:buClr>
+                <a:srgbClr val="FF0000"/>
+              </a:buClr>
+              <a:buSzPct val="110000"/>
+              <a:buFont typeface="Wingdings" panose="05000000000000000000" pitchFamily="2" charset="2"/>
+              <a:buChar char="§"/>
+              <a:defRPr sz="2800" kern="1200">
+                <a:solidFill>
+                  <a:schemeClr val="tx1"/>
+                </a:solidFill>
+                <a:latin typeface="+mn-lt"/>
+                <a:ea typeface="+mn-ea"/>
+                <a:cs typeface="+mn-cs"/>
+              </a:defRPr>
+            </a:lvl2pPr>
+            <a:lvl3pPr marL="1143000" indent="-228600" algn="l" defTabSz="914400" rtl="0" eaLnBrk="1" latinLnBrk="0" hangingPunct="1">
+              <a:spcBef>
+                <a:spcPct val="20000"/>
+              </a:spcBef>
+              <a:buFont typeface="Arial" panose="020B0604020202020204" pitchFamily="34" charset="0"/>
+              <a:buChar char="•"/>
+              <a:defRPr sz="2400" kern="1200">
+                <a:solidFill>
+                  <a:schemeClr val="tx1"/>
+                </a:solidFill>
+                <a:latin typeface="+mn-lt"/>
+                <a:ea typeface="+mn-ea"/>
+                <a:cs typeface="+mn-cs"/>
+              </a:defRPr>
+            </a:lvl3pPr>
+            <a:lvl4pPr marL="1600200" indent="-228600" algn="l" defTabSz="914400" rtl="0" eaLnBrk="1" latinLnBrk="0" hangingPunct="1">
+              <a:spcBef>
+                <a:spcPct val="20000"/>
+              </a:spcBef>
+              <a:buFont typeface="Arial" panose="020B0604020202020204" pitchFamily="34" charset="0"/>
+              <a:buChar char="–"/>
+              <a:defRPr sz="2000" kern="1200">
+                <a:solidFill>
+                  <a:schemeClr val="tx1"/>
+                </a:solidFill>
+                <a:latin typeface="+mn-lt"/>
+                <a:ea typeface="+mn-ea"/>
+                <a:cs typeface="+mn-cs"/>
+              </a:defRPr>
+            </a:lvl4pPr>
+            <a:lvl5pPr marL="2057400" indent="-228600" algn="l" defTabSz="914400" rtl="0" eaLnBrk="1" latinLnBrk="0" hangingPunct="1">
+              <a:spcBef>
+                <a:spcPct val="20000"/>
+              </a:spcBef>
+              <a:buFont typeface="Arial" panose="020B0604020202020204" pitchFamily="34" charset="0"/>
+              <a:buChar char="»"/>
+              <a:defRPr sz="2000" kern="1200">
+                <a:solidFill>
+                  <a:schemeClr val="tx1"/>
+                </a:solidFill>
+                <a:latin typeface="+mn-lt"/>
+                <a:ea typeface="+mn-ea"/>
+                <a:cs typeface="+mn-cs"/>
+              </a:defRPr>
+            </a:lvl5pPr>
+            <a:lvl6pPr marL="2514600" indent="-228600" algn="l" defTabSz="914400" rtl="0" eaLnBrk="1" latinLnBrk="0" hangingPunct="1">
+              <a:spcBef>
+                <a:spcPct val="20000"/>
+              </a:spcBef>
+              <a:buFont typeface="Arial" panose="020B0604020202020204" pitchFamily="34" charset="0"/>
+              <a:buChar char="•"/>
+              <a:defRPr sz="2000" kern="1200">
+                <a:solidFill>
+                  <a:schemeClr val="tx1"/>
+                </a:solidFill>
+                <a:latin typeface="+mn-lt"/>
+                <a:ea typeface="+mn-ea"/>
+                <a:cs typeface="+mn-cs"/>
+              </a:defRPr>
+            </a:lvl6pPr>
+            <a:lvl7pPr marL="2971800" indent="-228600" algn="l" defTabSz="914400" rtl="0" eaLnBrk="1" latinLnBrk="0" hangingPunct="1">
+              <a:spcBef>
+                <a:spcPct val="20000"/>
+              </a:spcBef>
+              <a:buFont typeface="Arial" panose="020B0604020202020204" pitchFamily="34" charset="0"/>
+              <a:buChar char="•"/>
+              <a:defRPr sz="2000" kern="1200">
+                <a:solidFill>
+                  <a:schemeClr val="tx1"/>
+                </a:solidFill>
+                <a:latin typeface="+mn-lt"/>
+                <a:ea typeface="+mn-ea"/>
+                <a:cs typeface="+mn-cs"/>
+              </a:defRPr>
+            </a:lvl7pPr>
+            <a:lvl8pPr marL="3429000" indent="-228600" algn="l" defTabSz="914400" rtl="0" eaLnBrk="1" latinLnBrk="0" hangingPunct="1">
+              <a:spcBef>
+                <a:spcPct val="20000"/>
+              </a:spcBef>
+              <a:buFont typeface="Arial" panose="020B0604020202020204" pitchFamily="34" charset="0"/>
+              <a:buChar char="•"/>
+              <a:defRPr sz="2000" kern="1200">
+                <a:solidFill>
+                  <a:schemeClr val="tx1"/>
+                </a:solidFill>
+                <a:latin typeface="+mn-lt"/>
+                <a:ea typeface="+mn-ea"/>
+                <a:cs typeface="+mn-cs"/>
+              </a:defRPr>
+            </a:lvl8pPr>
+            <a:lvl9pPr marL="3886200" indent="-228600" algn="l" defTabSz="914400" rtl="0" eaLnBrk="1" latinLnBrk="0" hangingPunct="1">
+              <a:spcBef>
+                <a:spcPct val="20000"/>
+              </a:spcBef>
+              <a:buFont typeface="Arial" panose="020B0604020202020204" pitchFamily="34" charset="0"/>
+              <a:buChar char="•"/>
+              <a:defRPr sz="2000" kern="1200">
+                <a:solidFill>
+                  <a:schemeClr val="tx1"/>
+                </a:solidFill>
+                <a:latin typeface="+mn-lt"/>
+                <a:ea typeface="+mn-ea"/>
+                <a:cs typeface="+mn-cs"/>
+              </a:defRPr>
+            </a:lvl9pPr>
+          </a:lstStyle>
+          <a:p>
+            <a:r>
+              <a:rPr lang="en-US" b="1" dirty="0">
+                <a:solidFill>
+                  <a:schemeClr val="bg1"/>
+                </a:solidFill>
+              </a:rPr>
+              <a:t>Michael Friendly</a:t>
+            </a:r>
+          </a:p>
+          <a:p>
+            <a:endParaRPr lang="en-US" dirty="0"/>
+          </a:p>
+        </p:txBody>
+      </p:sp>
+      <p:pic>
+        <p:nvPicPr>
+          <p:cNvPr id="17" name="Picture 16">
+            <a:extLst>
+              <a:ext uri="{FF2B5EF4-FFF2-40B4-BE49-F238E27FC236}">
+                <a16:creationId xmlns:a16="http://schemas.microsoft.com/office/drawing/2014/main" id="{525E8C58-2513-02E3-A663-F8137F63A3E9}"/>
+              </a:ext>
+            </a:extLst>
+          </p:cNvPr>
+          <p:cNvPicPr>
+            <a:picLocks noChangeAspect="1"/>
+          </p:cNvPicPr>
+          <p:nvPr/>
+        </p:nvPicPr>
+        <p:blipFill>
+          <a:blip r:embed="rId8" cstate="print">
+            <a:extLst>
+              <a:ext uri="{28A0092B-C50C-407E-A947-70E740481C1C}">
+                <a14:useLocalDpi xmlns:a14="http://schemas.microsoft.com/office/drawing/2010/main" val="0"/>
+              </a:ext>
+            </a:extLst>
+          </a:blip>
+          <a:stretch>
+            <a:fillRect/>
+          </a:stretch>
+        </p:blipFill>
+        <p:spPr>
+          <a:xfrm>
+            <a:off x="6474310" y="223450"/>
+            <a:ext cx="1666800" cy="1666800"/>
+          </a:xfrm>
+          <a:prstGeom prst="rect">
+            <a:avLst/>
+          </a:prstGeom>
+        </p:spPr>
+      </p:pic>
+      <p:pic>
+        <p:nvPicPr>
+          <p:cNvPr id="19" name="Picture 18">
+            <a:extLst>
+              <a:ext uri="{FF2B5EF4-FFF2-40B4-BE49-F238E27FC236}">
+                <a16:creationId xmlns:a16="http://schemas.microsoft.com/office/drawing/2014/main" id="{592C9CDC-899C-60EC-BB55-6C5779245DA4}"/>
+              </a:ext>
+            </a:extLst>
+          </p:cNvPr>
+          <p:cNvPicPr>
+            <a:picLocks noChangeAspect="1"/>
+          </p:cNvPicPr>
+          <p:nvPr/>
+        </p:nvPicPr>
+        <p:blipFill>
+          <a:blip r:embed="rId9">
+            <a:extLst>
+              <a:ext uri="{28A0092B-C50C-407E-A947-70E740481C1C}">
+                <a14:useLocalDpi xmlns:a14="http://schemas.microsoft.com/office/drawing/2010/main" val="0"/>
+              </a:ext>
+            </a:extLst>
+          </a:blip>
+          <a:stretch>
+            <a:fillRect/>
+          </a:stretch>
+        </p:blipFill>
+        <p:spPr>
+          <a:xfrm>
+            <a:off x="6076336" y="5678136"/>
+            <a:ext cx="1033646" cy="779130"/>
           </a:xfrm>
           <a:prstGeom prst="rect">
             <a:avLst/>
@@ -3611,13 +3914,118 @@
     </p:spTree>
     <p:extLst>
       <p:ext uri="{BB962C8B-B14F-4D97-AF65-F5344CB8AC3E}">
-        <p14:creationId xmlns:p14="http://schemas.microsoft.com/office/powerpoint/2010/main" val="1970465655"/>
+        <p14:creationId xmlns:p14="http://schemas.microsoft.com/office/powerpoint/2010/main" val="2570832178"/>
       </p:ext>
     </p:extLst>
   </p:cSld>
   <p:clrMapOvr>
     <a:masterClrMapping/>
   </p:clrMapOvr>
+  <p:timing>
+    <p:tnLst>
+      <p:par>
+        <p:cTn id="1" dur="indefinite" restart="never" nodeType="tmRoot">
+          <p:childTnLst>
+            <p:seq concurrent="1" nextAc="seek">
+              <p:cTn id="2" dur="indefinite" nodeType="mainSeq">
+                <p:childTnLst>
+                  <p:par>
+                    <p:cTn id="3" fill="hold">
+                      <p:stCondLst>
+                        <p:cond delay="indefinite"/>
+                        <p:cond evt="onBegin" delay="0">
+                          <p:tn val="2"/>
+                        </p:cond>
+                      </p:stCondLst>
+                      <p:childTnLst>
+                        <p:par>
+                          <p:cTn id="4" fill="hold">
+                            <p:stCondLst>
+                              <p:cond delay="0"/>
+                            </p:stCondLst>
+                            <p:childTnLst>
+                              <p:par>
+                                <p:cTn id="5" presetID="1" presetClass="entr" presetSubtype="0" fill="hold" nodeType="withEffect">
+                                  <p:stCondLst>
+                                    <p:cond delay="0"/>
+                                  </p:stCondLst>
+                                  <p:childTnLst>
+                                    <p:set>
+                                      <p:cBhvr>
+                                        <p:cTn id="6" dur="1" fill="hold">
+                                          <p:stCondLst>
+                                            <p:cond delay="0"/>
+                                          </p:stCondLst>
+                                        </p:cTn>
+                                        <p:tgtEl>
+                                          <p:spTgt spid="5"/>
+                                        </p:tgtEl>
+                                        <p:attrNameLst>
+                                          <p:attrName>style.visibility</p:attrName>
+                                        </p:attrNameLst>
+                                      </p:cBhvr>
+                                      <p:to>
+                                        <p:strVal val="visible"/>
+                                      </p:to>
+                                    </p:set>
+                                  </p:childTnLst>
+                                </p:cTn>
+                              </p:par>
+                              <p:par>
+                                <p:cTn id="7" presetID="1" presetClass="entr" presetSubtype="0" fill="hold" nodeType="withEffect">
+                                  <p:stCondLst>
+                                    <p:cond delay="0"/>
+                                  </p:stCondLst>
+                                  <p:childTnLst>
+                                    <p:set>
+                                      <p:cBhvr>
+                                        <p:cTn id="8" dur="1" fill="hold">
+                                          <p:stCondLst>
+                                            <p:cond delay="0"/>
+                                          </p:stCondLst>
+                                        </p:cTn>
+                                        <p:tgtEl>
+                                          <p:spTgt spid="7"/>
+                                        </p:tgtEl>
+                                        <p:attrNameLst>
+                                          <p:attrName>style.visibility</p:attrName>
+                                        </p:attrNameLst>
+                                      </p:cBhvr>
+                                      <p:to>
+                                        <p:strVal val="visible"/>
+                                      </p:to>
+                                    </p:set>
+                                  </p:childTnLst>
+                                </p:cTn>
+                              </p:par>
+                            </p:childTnLst>
+                          </p:cTn>
+                        </p:par>
+                      </p:childTnLst>
+                    </p:cTn>
+                  </p:par>
+                </p:childTnLst>
+              </p:cTn>
+              <p:prevCondLst>
+                <p:cond evt="onPrev" delay="0">
+                  <p:tgtEl>
+                    <p:sldTgt/>
+                  </p:tgtEl>
+                </p:cond>
+              </p:prevCondLst>
+              <p:nextCondLst>
+                <p:cond evt="onNext" delay="0">
+                  <p:tgtEl>
+                    <p:sldTgt/>
+                  </p:tgtEl>
+                </p:cond>
+              </p:nextCondLst>
+            </p:seq>
+          </p:childTnLst>
+        </p:cTn>
+      </p:par>
+    </p:tnLst>
+  </p:timing>
 </p:sld>
 </file>
 
@@ -3656,7 +4064,7 @@
           <a:lstStyle/>
           <a:p>
             <a:r>
-              <a:rPr lang="en-US" dirty="0"/>
+              <a:rPr lang="en-CA" dirty="0"/>
               <a:t>Visualizing the results</a:t>
             </a:r>
           </a:p>
@@ -3680,6 +4088,153 @@
             <a:fld id="{621225AB-15B9-4C79-A121-04D1DC7E2307}" type="slidenum">
               <a:rPr lang="en-US" smtClean="0"/>
               <a:t>10</a:t>
+            </a:fld>
+            <a:endParaRPr lang="en-US"/>
+          </a:p>
+        </p:txBody>
+      </p:sp>
+      <p:pic>
+        <p:nvPicPr>
+          <p:cNvPr id="5122" name="Picture 2" descr="C:\Users\friendly\Pictures\2018-Provo\IMG_20180225_1445314-smaller.jpg"/>
+          <p:cNvPicPr>
+            <a:picLocks noChangeAspect="1" noChangeArrowheads="1"/>
+          </p:cNvPicPr>
+          <p:nvPr/>
+        </p:nvPicPr>
+        <p:blipFill>
+          <a:blip r:embed="rId2">
+            <a:extLst>
+              <a:ext uri="{28A0092B-C50C-407E-A947-70E740481C1C}">
+                <a14:useLocalDpi xmlns:a14="http://schemas.microsoft.com/office/drawing/2010/main" val="0"/>
+              </a:ext>
+            </a:extLst>
+          </a:blip>
+          <a:srcRect/>
+          <a:stretch>
+            <a:fillRect/>
+          </a:stretch>
+        </p:blipFill>
+        <p:spPr bwMode="auto">
+          <a:xfrm>
+            <a:off x="1066800" y="1981200"/>
+            <a:ext cx="6960870" cy="4640580"/>
+          </a:xfrm>
+          <a:prstGeom prst="rect">
+            <a:avLst/>
+          </a:prstGeom>
+          <a:noFill/>
+          <a:extLst>
+            <a:ext uri="{909E8E84-426E-40DD-AFC4-6F175D3DCCD1}">
+              <a14:hiddenFill xmlns:a14="http://schemas.microsoft.com/office/drawing/2010/main">
+                <a:solidFill>
+                  <a:srgbClr val="FFFFFF"/>
+                </a:solidFill>
+              </a14:hiddenFill>
+            </a:ext>
+          </a:extLst>
+        </p:spPr>
+      </p:pic>
+      <p:sp>
+        <p:nvSpPr>
+          <p:cNvPr id="4" name="TextBox 3"/>
+          <p:cNvSpPr txBox="1"/>
+          <p:nvPr/>
+        </p:nvSpPr>
+        <p:spPr>
+          <a:xfrm>
+            <a:off x="457200" y="1143000"/>
+            <a:ext cx="8229600" cy="461665"/>
+          </a:xfrm>
+          <a:prstGeom prst="rect">
+            <a:avLst/>
+          </a:prstGeom>
+          <a:noFill/>
+        </p:spPr>
+        <p:txBody>
+          <a:bodyPr wrap="square" rtlCol="0">
+            <a:spAutoFit/>
+          </a:bodyPr>
+          <a:lstStyle/>
+          <a:p>
+            <a:r>
+              <a:rPr lang="en-US" sz="2400" dirty="0"/>
+              <a:t>Successful visualizations require some time for reflection</a:t>
+            </a:r>
+          </a:p>
+        </p:txBody>
+      </p:sp>
+    </p:spTree>
+    <p:extLst>
+      <p:ext uri="{BB962C8B-B14F-4D97-AF65-F5344CB8AC3E}">
+        <p14:creationId xmlns:p14="http://schemas.microsoft.com/office/powerpoint/2010/main" val="415895312"/>
+      </p:ext>
+    </p:extLst>
+  </p:cSld>
+  <p:clrMapOvr>
+    <a:masterClrMapping/>
+  </p:clrMapOvr>
+</p:sld>
+</file>
+
+<file path=ppt/slides/slide11.xml><?xml version="1.0" encoding="utf-8"?>
+<p:sld xmlns:a="http://schemas.openxmlformats.org/drawingml/2006/main" xmlns:r="http://schemas.openxmlformats.org/officeDocument/2006/relationships" xmlns:p="http://schemas.openxmlformats.org/presentationml/2006/main">
+  <p:cSld>
+    <p:spTree>
+      <p:nvGrpSpPr>
+        <p:cNvPr id="1" name=""/>
+        <p:cNvGrpSpPr/>
+        <p:nvPr/>
+      </p:nvGrpSpPr>
+      <p:grpSpPr>
+        <a:xfrm>
+          <a:off x="0" y="0"/>
+          <a:ext cx="0" cy="0"/>
+          <a:chOff x="0" y="0"/>
+          <a:chExt cx="0" cy="0"/>
+        </a:xfrm>
+      </p:grpSpPr>
+      <p:sp>
+        <p:nvSpPr>
+          <p:cNvPr id="2" name="Title 1"/>
+          <p:cNvSpPr>
+            <a:spLocks noGrp="1"/>
+          </p:cNvSpPr>
+          <p:nvPr>
+            <p:ph type="title"/>
+          </p:nvPr>
+        </p:nvSpPr>
+        <p:spPr/>
+        <p:txBody>
+          <a:bodyPr>
+            <a:normAutofit fontScale="90000"/>
+          </a:bodyPr>
+          <a:lstStyle/>
+          <a:p>
+            <a:r>
+              <a:rPr lang="en-US" dirty="0"/>
+              <a:t>Visualizing the results</a:t>
+            </a:r>
+          </a:p>
+        </p:txBody>
+      </p:sp>
+      <p:sp>
+        <p:nvSpPr>
+          <p:cNvPr id="3" name="Slide Number Placeholder 2"/>
+          <p:cNvSpPr>
+            <a:spLocks noGrp="1"/>
+          </p:cNvSpPr>
+          <p:nvPr>
+            <p:ph type="sldNum" sz="quarter" idx="12"/>
+          </p:nvPr>
+        </p:nvSpPr>
+        <p:spPr/>
+        <p:txBody>
+          <a:bodyPr/>
+          <a:lstStyle/>
+          <a:p>
+            <a:fld id="{621225AB-15B9-4C79-A121-04D1DC7E2307}" type="slidenum">
+              <a:rPr lang="en-US" smtClean="0"/>
+              <a:t>11</a:t>
             </a:fld>
             <a:endParaRPr lang="en-US"/>
           </a:p>
@@ -3902,7 +4457,7 @@
 </p:sld>
 </file>
 
-<file path=ppt/slides/slide11.xml><?xml version="1.0" encoding="utf-8"?>
+<file path=ppt/slides/slide12.xml><?xml version="1.0" encoding="utf-8"?>
 <p:sld xmlns:a="http://schemas.openxmlformats.org/drawingml/2006/main" xmlns:r="http://schemas.openxmlformats.org/officeDocument/2006/relationships" xmlns:p="http://schemas.openxmlformats.org/presentationml/2006/main">
   <p:cSld>
     <p:spTree>
@@ -3972,7 +4527,7 @@
           <a:p>
             <a:fld id="{621225AB-15B9-4C79-A121-04D1DC7E2307}" type="slidenum">
               <a:rPr lang="en-US" smtClean="0"/>
-              <a:t>11</a:t>
+              <a:t>12</a:t>
             </a:fld>
             <a:endParaRPr lang="en-US"/>
           </a:p>
@@ -4086,7 +4641,7 @@
 </p:sld>
 </file>
 
-<file path=ppt/slides/slide12.xml><?xml version="1.0" encoding="utf-8"?>
+<file path=ppt/slides/slide13.xml><?xml version="1.0" encoding="utf-8"?>
 <p:sld xmlns:a="http://schemas.openxmlformats.org/drawingml/2006/main" xmlns:r="http://schemas.openxmlformats.org/officeDocument/2006/relationships" xmlns:p="http://schemas.openxmlformats.org/presentationml/2006/main">
   <p:cSld>
     <p:bg>
@@ -4746,7 +5301,7 @@
                   <a:spcPts val="600"/>
                 </a:spcAft>
               </a:pPr>
-              <a:t>12</a:t>
+              <a:t>13</a:t>
             </a:fld>
             <a:endParaRPr lang="en-US" sz="1600"/>
           </a:p>
@@ -4824,7 +5379,7 @@
               </a:spcAft>
             </a:pPr>
             <a:r>
-              <a:rPr lang="en-US" sz="2000">
+              <a:rPr lang="en-US" sz="2000" dirty="0">
                 <a:solidFill>
                   <a:srgbClr val="000000"/>
                 </a:solidFill>
@@ -4832,7 +5387,7 @@
               <a:t>The research reported</a:t>
             </a:r>
             <a:r>
-              <a:rPr lang="en-US" sz="2000" baseline="30000">
+              <a:rPr lang="en-US" sz="2000" baseline="30000" dirty="0">
                 <a:solidFill>
                   <a:srgbClr val="FF0000"/>
                 </a:solidFill>
@@ -4840,15 +5395,15 @@
               <a:t>*</a:t>
             </a:r>
             <a:r>
-              <a:rPr lang="en-US" sz="2000">
+              <a:rPr lang="en-US" sz="2000" dirty="0">
                 <a:solidFill>
                   <a:srgbClr val="000000"/>
                 </a:solidFill>
               </a:rPr>
-              <a:t> here was given the February 2023 </a:t>
-            </a:r>
-            <a:r>
-              <a:rPr lang="en-US" sz="2000" i="1">
+              <a:t> here was given the February 2026 </a:t>
+            </a:r>
+            <a:r>
+              <a:rPr lang="en-US" sz="2000" i="1" dirty="0">
                 <a:solidFill>
                   <a:srgbClr val="000000"/>
                 </a:solidFill>
@@ -4856,7 +5411,7 @@
               <a:t>Red Stripe </a:t>
             </a:r>
             <a:r>
-              <a:rPr lang="en-US" sz="2000">
+              <a:rPr lang="en-US" sz="2000" dirty="0">
                 <a:solidFill>
                   <a:srgbClr val="000000"/>
                 </a:solidFill>
@@ -4864,14 +5419,14 @@
               <a:t>Award by the </a:t>
             </a:r>
             <a:r>
-              <a:rPr lang="en-US" sz="2000" b="1">
+              <a:rPr lang="en-US" sz="2000" b="1" dirty="0">
                 <a:solidFill>
                   <a:srgbClr val="000000"/>
                 </a:solidFill>
               </a:rPr>
               <a:t>Deep Question Research Institute</a:t>
             </a:r>
-            <a:endParaRPr lang="en-US" sz="2000" b="1"/>
+            <a:endParaRPr lang="en-US" sz="2000" b="1" dirty="0"/>
           </a:p>
         </p:txBody>
       </p:sp>
@@ -5146,7 +5701,7 @@
 </p:sld>
 </file>
 
-<file path=ppt/slides/slide13.xml><?xml version="1.0" encoding="utf-8"?>
+<file path=ppt/slides/slide14.xml><?xml version="1.0" encoding="utf-8"?>
 <p:sld xmlns:a="http://schemas.openxmlformats.org/drawingml/2006/main" xmlns:r="http://schemas.openxmlformats.org/officeDocument/2006/relationships" xmlns:p="http://schemas.openxmlformats.org/presentationml/2006/main">
   <p:cSld>
     <p:spTree>
@@ -5165,6 +5720,1599 @@
       </p:grpSpPr>
       <p:sp>
         <p:nvSpPr>
+          <p:cNvPr id="2" name="Title 1">
+            <a:extLst>
+              <a:ext uri="{FF2B5EF4-FFF2-40B4-BE49-F238E27FC236}">
+                <a16:creationId xmlns:a16="http://schemas.microsoft.com/office/drawing/2014/main" id="{21B61C7B-610E-9F97-B4FC-637B005226B2}"/>
+              </a:ext>
+            </a:extLst>
+          </p:cNvPr>
+          <p:cNvSpPr>
+            <a:spLocks noGrp="1"/>
+          </p:cNvSpPr>
+          <p:nvPr>
+            <p:ph type="title"/>
+          </p:nvPr>
+        </p:nvSpPr>
+        <p:spPr/>
+        <p:txBody>
+          <a:bodyPr>
+            <a:normAutofit fontScale="90000"/>
+          </a:bodyPr>
+          <a:lstStyle/>
+          <a:p>
+            <a:r>
+              <a:rPr lang="en-CA" dirty="0"/>
+              <a:t>Expanding scope: Antigua experiment</a:t>
+            </a:r>
+          </a:p>
+        </p:txBody>
+      </p:sp>
+      <p:sp>
+        <p:nvSpPr>
+          <p:cNvPr id="3" name="Slide Number Placeholder 2">
+            <a:extLst>
+              <a:ext uri="{FF2B5EF4-FFF2-40B4-BE49-F238E27FC236}">
+                <a16:creationId xmlns:a16="http://schemas.microsoft.com/office/drawing/2014/main" id="{69252948-7DFF-6B99-6642-85172C7262DD}"/>
+              </a:ext>
+            </a:extLst>
+          </p:cNvPr>
+          <p:cNvSpPr>
+            <a:spLocks noGrp="1"/>
+          </p:cNvSpPr>
+          <p:nvPr>
+            <p:ph type="sldNum" sz="quarter" idx="12"/>
+          </p:nvPr>
+        </p:nvSpPr>
+        <p:spPr/>
+        <p:txBody>
+          <a:bodyPr/>
+          <a:lstStyle/>
+          <a:p>
+            <a:fld id="{621225AB-15B9-4C79-A121-04D1DC7E2307}" type="slidenum">
+              <a:rPr lang="en-US" smtClean="0"/>
+              <a:t>14</a:t>
+            </a:fld>
+            <a:endParaRPr lang="en-US" dirty="0"/>
+          </a:p>
+        </p:txBody>
+      </p:sp>
+      <p:sp>
+        <p:nvSpPr>
+          <p:cNvPr id="4" name="TextBox 3">
+            <a:extLst>
+              <a:ext uri="{FF2B5EF4-FFF2-40B4-BE49-F238E27FC236}">
+                <a16:creationId xmlns:a16="http://schemas.microsoft.com/office/drawing/2014/main" id="{58A05394-EEF2-91F2-F7C9-7EB8A389C962}"/>
+              </a:ext>
+            </a:extLst>
+          </p:cNvPr>
+          <p:cNvSpPr txBox="1"/>
+          <p:nvPr/>
+        </p:nvSpPr>
+        <p:spPr>
+          <a:xfrm>
+            <a:off x="457200" y="1219200"/>
+            <a:ext cx="8229600" cy="400110"/>
+          </a:xfrm>
+          <a:prstGeom prst="rect">
+            <a:avLst/>
+          </a:prstGeom>
+          <a:noFill/>
+        </p:spPr>
+        <p:txBody>
+          <a:bodyPr wrap="square" rtlCol="0">
+            <a:spAutoFit/>
+          </a:bodyPr>
+          <a:lstStyle/>
+          <a:p>
+            <a:r>
+              <a:rPr lang="en-CA" sz="2000" dirty="0"/>
+              <a:t>A new, more comprehensive experiment was just conducted in Antigua </a:t>
+            </a:r>
+          </a:p>
+        </p:txBody>
+      </p:sp>
+      <p:sp>
+        <p:nvSpPr>
+          <p:cNvPr id="5" name="TextBox 4">
+            <a:extLst>
+              <a:ext uri="{FF2B5EF4-FFF2-40B4-BE49-F238E27FC236}">
+                <a16:creationId xmlns:a16="http://schemas.microsoft.com/office/drawing/2014/main" id="{D9F0699C-F3C6-FDC5-B1E7-F6ED24B86A7F}"/>
+              </a:ext>
+            </a:extLst>
+          </p:cNvPr>
+          <p:cNvSpPr txBox="1"/>
+          <p:nvPr/>
+        </p:nvSpPr>
+        <p:spPr>
+          <a:xfrm>
+            <a:off x="457200" y="1752600"/>
+            <a:ext cx="1905000" cy="461665"/>
+          </a:xfrm>
+          <a:prstGeom prst="rect">
+            <a:avLst/>
+          </a:prstGeom>
+          <a:noFill/>
+        </p:spPr>
+        <p:txBody>
+          <a:bodyPr wrap="square" rtlCol="0">
+            <a:spAutoFit/>
+          </a:bodyPr>
+          <a:lstStyle/>
+          <a:p>
+            <a:r>
+              <a:rPr lang="en-CA" sz="2400" dirty="0"/>
+              <a:t>Species</a:t>
+            </a:r>
+          </a:p>
+        </p:txBody>
+      </p:sp>
+      <p:sp>
+        <p:nvSpPr>
+          <p:cNvPr id="10" name="TextBox 9">
+            <a:extLst>
+              <a:ext uri="{FF2B5EF4-FFF2-40B4-BE49-F238E27FC236}">
+                <a16:creationId xmlns:a16="http://schemas.microsoft.com/office/drawing/2014/main" id="{0B10CE62-C8F2-2C70-35D4-D993B00BE015}"/>
+              </a:ext>
+            </a:extLst>
+          </p:cNvPr>
+          <p:cNvSpPr txBox="1"/>
+          <p:nvPr/>
+        </p:nvSpPr>
+        <p:spPr>
+          <a:xfrm>
+            <a:off x="533400" y="3581400"/>
+            <a:ext cx="1219200" cy="461665"/>
+          </a:xfrm>
+          <a:prstGeom prst="rect">
+            <a:avLst/>
+          </a:prstGeom>
+          <a:noFill/>
+        </p:spPr>
+        <p:txBody>
+          <a:bodyPr wrap="square" rtlCol="0">
+            <a:spAutoFit/>
+          </a:bodyPr>
+          <a:lstStyle/>
+          <a:p>
+            <a:r>
+              <a:rPr lang="en-CA" sz="2400" dirty="0"/>
+              <a:t>Stimuli</a:t>
+            </a:r>
+          </a:p>
+        </p:txBody>
+      </p:sp>
+      <p:grpSp>
+        <p:nvGrpSpPr>
+          <p:cNvPr id="23" name="Group 22">
+            <a:extLst>
+              <a:ext uri="{FF2B5EF4-FFF2-40B4-BE49-F238E27FC236}">
+                <a16:creationId xmlns:a16="http://schemas.microsoft.com/office/drawing/2014/main" id="{0657095E-35A9-CE7E-2AD0-E18863F98AD9}"/>
+              </a:ext>
+            </a:extLst>
+          </p:cNvPr>
+          <p:cNvGrpSpPr/>
+          <p:nvPr/>
+        </p:nvGrpSpPr>
+        <p:grpSpPr>
+          <a:xfrm>
+            <a:off x="1790699" y="1752599"/>
+            <a:ext cx="936000" cy="1238915"/>
+            <a:chOff x="1790699" y="1752599"/>
+            <a:chExt cx="936000" cy="1238915"/>
+          </a:xfrm>
+        </p:grpSpPr>
+        <p:pic>
+          <p:nvPicPr>
+            <p:cNvPr id="6" name="Picture 5" descr="A picture containing text&#10;&#10;Description automatically generated">
+              <a:extLst>
+                <a:ext uri="{FF2B5EF4-FFF2-40B4-BE49-F238E27FC236}">
+                  <a16:creationId xmlns:a16="http://schemas.microsoft.com/office/drawing/2014/main" id="{D3869627-3063-A0DD-54F9-F3B9F061E4AC}"/>
+                </a:ext>
+              </a:extLst>
+            </p:cNvPr>
+            <p:cNvPicPr>
+              <a:picLocks noChangeAspect="1"/>
+            </p:cNvPicPr>
+            <p:nvPr/>
+          </p:nvPicPr>
+          <p:blipFill>
+            <a:blip r:embed="rId2">
+              <a:extLst>
+                <a:ext uri="{28A0092B-C50C-407E-A947-70E740481C1C}">
+                  <a14:useLocalDpi xmlns:a14="http://schemas.microsoft.com/office/drawing/2010/main" val="0"/>
+                </a:ext>
+              </a:extLst>
+            </a:blip>
+            <a:stretch>
+              <a:fillRect/>
+            </a:stretch>
+          </p:blipFill>
+          <p:spPr>
+            <a:xfrm>
+              <a:off x="1790699" y="1752599"/>
+              <a:ext cx="936000" cy="936000"/>
+            </a:xfrm>
+            <a:prstGeom prst="rect">
+              <a:avLst/>
+            </a:prstGeom>
+          </p:spPr>
+        </p:pic>
+        <p:sp>
+          <p:nvSpPr>
+            <p:cNvPr id="11" name="TextBox 10">
+              <a:extLst>
+                <a:ext uri="{FF2B5EF4-FFF2-40B4-BE49-F238E27FC236}">
+                  <a16:creationId xmlns:a16="http://schemas.microsoft.com/office/drawing/2014/main" id="{DD3E64C9-1CCE-4F6E-C07D-D7C4F788030A}"/>
+                </a:ext>
+              </a:extLst>
+            </p:cNvPr>
+            <p:cNvSpPr txBox="1"/>
+            <p:nvPr/>
+          </p:nvSpPr>
+          <p:spPr>
+            <a:xfrm>
+              <a:off x="1790699" y="2622182"/>
+              <a:ext cx="936000" cy="369332"/>
+            </a:xfrm>
+            <a:prstGeom prst="rect">
+              <a:avLst/>
+            </a:prstGeom>
+            <a:noFill/>
+          </p:spPr>
+          <p:txBody>
+            <a:bodyPr wrap="square" rtlCol="0">
+              <a:spAutoFit/>
+            </a:bodyPr>
+            <a:lstStyle/>
+            <a:p>
+              <a:pPr algn="ctr"/>
+              <a:r>
+                <a:rPr lang="en-CA" dirty="0"/>
+                <a:t>shark</a:t>
+              </a:r>
+            </a:p>
+          </p:txBody>
+        </p:sp>
+      </p:grpSp>
+      <p:grpSp>
+        <p:nvGrpSpPr>
+          <p:cNvPr id="24" name="Group 23">
+            <a:extLst>
+              <a:ext uri="{FF2B5EF4-FFF2-40B4-BE49-F238E27FC236}">
+                <a16:creationId xmlns:a16="http://schemas.microsoft.com/office/drawing/2014/main" id="{37BEE62F-FE95-2918-3CC7-2832F7009672}"/>
+              </a:ext>
+            </a:extLst>
+          </p:cNvPr>
+          <p:cNvGrpSpPr/>
+          <p:nvPr/>
+        </p:nvGrpSpPr>
+        <p:grpSpPr>
+          <a:xfrm>
+            <a:off x="3970275" y="1785534"/>
+            <a:ext cx="1403225" cy="1205980"/>
+            <a:chOff x="3970275" y="1785534"/>
+            <a:chExt cx="1403225" cy="1205980"/>
+          </a:xfrm>
+        </p:grpSpPr>
+        <p:pic>
+          <p:nvPicPr>
+            <p:cNvPr id="9" name="Picture 8" descr="A black and white panda&#10;&#10;Description automatically generated with low confidence">
+              <a:extLst>
+                <a:ext uri="{FF2B5EF4-FFF2-40B4-BE49-F238E27FC236}">
+                  <a16:creationId xmlns:a16="http://schemas.microsoft.com/office/drawing/2014/main" id="{C1CADBFF-9413-B587-0100-277AD5C0A038}"/>
+                </a:ext>
+              </a:extLst>
+            </p:cNvPr>
+            <p:cNvPicPr>
+              <a:picLocks noChangeAspect="1"/>
+            </p:cNvPicPr>
+            <p:nvPr/>
+          </p:nvPicPr>
+          <p:blipFill>
+            <a:blip r:embed="rId3" cstate="print">
+              <a:extLst>
+                <a:ext uri="{28A0092B-C50C-407E-A947-70E740481C1C}">
+                  <a14:useLocalDpi xmlns:a14="http://schemas.microsoft.com/office/drawing/2010/main" val="0"/>
+                </a:ext>
+              </a:extLst>
+            </a:blip>
+            <a:stretch>
+              <a:fillRect/>
+            </a:stretch>
+          </p:blipFill>
+          <p:spPr>
+            <a:xfrm>
+              <a:off x="3970275" y="1785534"/>
+              <a:ext cx="1403225" cy="936000"/>
+            </a:xfrm>
+            <a:prstGeom prst="rect">
+              <a:avLst/>
+            </a:prstGeom>
+          </p:spPr>
+        </p:pic>
+        <p:sp>
+          <p:nvSpPr>
+            <p:cNvPr id="12" name="TextBox 11">
+              <a:extLst>
+                <a:ext uri="{FF2B5EF4-FFF2-40B4-BE49-F238E27FC236}">
+                  <a16:creationId xmlns:a16="http://schemas.microsoft.com/office/drawing/2014/main" id="{23EE98E8-8FDE-8411-DB2A-C5BFF8FEA58E}"/>
+                </a:ext>
+              </a:extLst>
+            </p:cNvPr>
+            <p:cNvSpPr txBox="1"/>
+            <p:nvPr/>
+          </p:nvSpPr>
+          <p:spPr>
+            <a:xfrm>
+              <a:off x="4203887" y="2622182"/>
+              <a:ext cx="936000" cy="369332"/>
+            </a:xfrm>
+            <a:prstGeom prst="rect">
+              <a:avLst/>
+            </a:prstGeom>
+            <a:noFill/>
+          </p:spPr>
+          <p:txBody>
+            <a:bodyPr wrap="square" rtlCol="0">
+              <a:spAutoFit/>
+            </a:bodyPr>
+            <a:lstStyle/>
+            <a:p>
+              <a:pPr algn="ctr"/>
+              <a:r>
+                <a:rPr lang="en-CA" dirty="0"/>
+                <a:t>turtle</a:t>
+              </a:r>
+            </a:p>
+          </p:txBody>
+        </p:sp>
+      </p:grpSp>
+      <p:grpSp>
+        <p:nvGrpSpPr>
+          <p:cNvPr id="25" name="Group 24">
+            <a:extLst>
+              <a:ext uri="{FF2B5EF4-FFF2-40B4-BE49-F238E27FC236}">
+                <a16:creationId xmlns:a16="http://schemas.microsoft.com/office/drawing/2014/main" id="{4A719447-55CF-8ABC-EB87-FA1DCD9582C2}"/>
+              </a:ext>
+            </a:extLst>
+          </p:cNvPr>
+          <p:cNvGrpSpPr/>
+          <p:nvPr/>
+        </p:nvGrpSpPr>
+        <p:grpSpPr>
+          <a:xfrm>
+            <a:off x="6569279" y="1785534"/>
+            <a:ext cx="1241761" cy="1203522"/>
+            <a:chOff x="6569279" y="1785534"/>
+            <a:chExt cx="1241761" cy="1203522"/>
+          </a:xfrm>
+        </p:grpSpPr>
+        <p:pic>
+          <p:nvPicPr>
+            <p:cNvPr id="8" name="Picture 7">
+              <a:extLst>
+                <a:ext uri="{FF2B5EF4-FFF2-40B4-BE49-F238E27FC236}">
+                  <a16:creationId xmlns:a16="http://schemas.microsoft.com/office/drawing/2014/main" id="{3E91982D-E28E-0E90-9D80-078471AC81D7}"/>
+                </a:ext>
+              </a:extLst>
+            </p:cNvPr>
+            <p:cNvPicPr>
+              <a:picLocks noChangeAspect="1"/>
+            </p:cNvPicPr>
+            <p:nvPr/>
+          </p:nvPicPr>
+          <p:blipFill>
+            <a:blip r:embed="rId4">
+              <a:extLst>
+                <a:ext uri="{28A0092B-C50C-407E-A947-70E740481C1C}">
+                  <a14:useLocalDpi xmlns:a14="http://schemas.microsoft.com/office/drawing/2010/main" val="0"/>
+                </a:ext>
+              </a:extLst>
+            </a:blip>
+            <a:stretch>
+              <a:fillRect/>
+            </a:stretch>
+          </p:blipFill>
+          <p:spPr>
+            <a:xfrm>
+              <a:off x="6569279" y="1785534"/>
+              <a:ext cx="1241761" cy="936000"/>
+            </a:xfrm>
+            <a:prstGeom prst="rect">
+              <a:avLst/>
+            </a:prstGeom>
+          </p:spPr>
+        </p:pic>
+        <p:sp>
+          <p:nvSpPr>
+            <p:cNvPr id="13" name="TextBox 12">
+              <a:extLst>
+                <a:ext uri="{FF2B5EF4-FFF2-40B4-BE49-F238E27FC236}">
+                  <a16:creationId xmlns:a16="http://schemas.microsoft.com/office/drawing/2014/main" id="{A864E3D5-B4BD-90E2-5308-0EAD79312655}"/>
+                </a:ext>
+              </a:extLst>
+            </p:cNvPr>
+            <p:cNvSpPr txBox="1"/>
+            <p:nvPr/>
+          </p:nvSpPr>
+          <p:spPr>
+            <a:xfrm>
+              <a:off x="6722159" y="2619724"/>
+              <a:ext cx="936000" cy="369332"/>
+            </a:xfrm>
+            <a:prstGeom prst="rect">
+              <a:avLst/>
+            </a:prstGeom>
+            <a:noFill/>
+          </p:spPr>
+          <p:txBody>
+            <a:bodyPr wrap="square" rtlCol="0">
+              <a:spAutoFit/>
+            </a:bodyPr>
+            <a:lstStyle/>
+            <a:p>
+              <a:pPr algn="ctr"/>
+              <a:r>
+                <a:rPr lang="en-CA" dirty="0"/>
+                <a:t>stingray</a:t>
+              </a:r>
+            </a:p>
+          </p:txBody>
+        </p:sp>
+      </p:grpSp>
+      <p:grpSp>
+        <p:nvGrpSpPr>
+          <p:cNvPr id="14" name="Group 13">
+            <a:extLst>
+              <a:ext uri="{FF2B5EF4-FFF2-40B4-BE49-F238E27FC236}">
+                <a16:creationId xmlns:a16="http://schemas.microsoft.com/office/drawing/2014/main" id="{F358D455-F43A-4BBD-4DAF-ACEFB8542ED4}"/>
+              </a:ext>
+            </a:extLst>
+          </p:cNvPr>
+          <p:cNvGrpSpPr/>
+          <p:nvPr/>
+        </p:nvGrpSpPr>
+        <p:grpSpPr>
+          <a:xfrm>
+            <a:off x="1752600" y="3508970"/>
+            <a:ext cx="1687097" cy="2172705"/>
+            <a:chOff x="683911" y="3759227"/>
+            <a:chExt cx="1687097" cy="2172705"/>
+          </a:xfrm>
+        </p:grpSpPr>
+        <p:pic>
+          <p:nvPicPr>
+            <p:cNvPr id="15" name="Picture 14">
+              <a:extLst>
+                <a:ext uri="{FF2B5EF4-FFF2-40B4-BE49-F238E27FC236}">
+                  <a16:creationId xmlns:a16="http://schemas.microsoft.com/office/drawing/2014/main" id="{99DB02FE-011C-03D6-36C3-E0AD0735FDA2}"/>
+                </a:ext>
+              </a:extLst>
+            </p:cNvPr>
+            <p:cNvPicPr>
+              <a:picLocks noChangeAspect="1"/>
+            </p:cNvPicPr>
+            <p:nvPr/>
+          </p:nvPicPr>
+          <p:blipFill>
+            <a:blip r:embed="rId5">
+              <a:extLst>
+                <a:ext uri="{28A0092B-C50C-407E-A947-70E740481C1C}">
+                  <a14:useLocalDpi xmlns:a14="http://schemas.microsoft.com/office/drawing/2010/main" val="0"/>
+                </a:ext>
+              </a:extLst>
+            </a:blip>
+            <a:stretch>
+              <a:fillRect/>
+            </a:stretch>
+          </p:blipFill>
+          <p:spPr>
+            <a:xfrm>
+              <a:off x="683911" y="3759227"/>
+              <a:ext cx="1685208" cy="1711437"/>
+            </a:xfrm>
+            <a:prstGeom prst="rect">
+              <a:avLst/>
+            </a:prstGeom>
+          </p:spPr>
+        </p:pic>
+        <p:sp>
+          <p:nvSpPr>
+            <p:cNvPr id="16" name="TextBox 15">
+              <a:extLst>
+                <a:ext uri="{FF2B5EF4-FFF2-40B4-BE49-F238E27FC236}">
+                  <a16:creationId xmlns:a16="http://schemas.microsoft.com/office/drawing/2014/main" id="{2C6BDDC7-C7DE-6F6C-6175-92D27A0853D3}"/>
+                </a:ext>
+              </a:extLst>
+            </p:cNvPr>
+            <p:cNvSpPr txBox="1"/>
+            <p:nvPr/>
+          </p:nvSpPr>
+          <p:spPr>
+            <a:xfrm>
+              <a:off x="685800" y="5562600"/>
+              <a:ext cx="1685208" cy="369332"/>
+            </a:xfrm>
+            <a:prstGeom prst="rect">
+              <a:avLst/>
+            </a:prstGeom>
+            <a:noFill/>
+          </p:spPr>
+          <p:txBody>
+            <a:bodyPr wrap="square" rtlCol="0">
+              <a:spAutoFit/>
+            </a:bodyPr>
+            <a:lstStyle/>
+            <a:p>
+              <a:pPr algn="ctr"/>
+              <a:r>
+                <a:rPr lang="en-CA" dirty="0"/>
+                <a:t>Conch pie</a:t>
+              </a:r>
+            </a:p>
+          </p:txBody>
+        </p:sp>
+      </p:grpSp>
+      <p:grpSp>
+        <p:nvGrpSpPr>
+          <p:cNvPr id="17" name="Group 16">
+            <a:extLst>
+              <a:ext uri="{FF2B5EF4-FFF2-40B4-BE49-F238E27FC236}">
+                <a16:creationId xmlns:a16="http://schemas.microsoft.com/office/drawing/2014/main" id="{8E05C2FA-5C3A-477D-FDB4-E44ECB0A65A2}"/>
+              </a:ext>
+            </a:extLst>
+          </p:cNvPr>
+          <p:cNvGrpSpPr/>
+          <p:nvPr/>
+        </p:nvGrpSpPr>
+        <p:grpSpPr>
+          <a:xfrm>
+            <a:off x="3829283" y="3581400"/>
+            <a:ext cx="1685208" cy="2237441"/>
+            <a:chOff x="6982931" y="3694491"/>
+            <a:chExt cx="1685208" cy="2237441"/>
+          </a:xfrm>
+        </p:grpSpPr>
+        <p:pic>
+          <p:nvPicPr>
+            <p:cNvPr id="18" name="Picture 17">
+              <a:extLst>
+                <a:ext uri="{FF2B5EF4-FFF2-40B4-BE49-F238E27FC236}">
+                  <a16:creationId xmlns:a16="http://schemas.microsoft.com/office/drawing/2014/main" id="{C8070634-5C83-DC23-DC64-22FB0B0F2DB3}"/>
+                </a:ext>
+              </a:extLst>
+            </p:cNvPr>
+            <p:cNvPicPr>
+              <a:picLocks noChangeAspect="1"/>
+            </p:cNvPicPr>
+            <p:nvPr/>
+          </p:nvPicPr>
+          <p:blipFill>
+            <a:blip r:embed="rId6">
+              <a:extLst>
+                <a:ext uri="{28A0092B-C50C-407E-A947-70E740481C1C}">
+                  <a14:useLocalDpi xmlns:a14="http://schemas.microsoft.com/office/drawing/2010/main" val="0"/>
+                </a:ext>
+              </a:extLst>
+            </a:blip>
+            <a:stretch>
+              <a:fillRect/>
+            </a:stretch>
+          </p:blipFill>
+          <p:spPr>
+            <a:xfrm>
+              <a:off x="7026626" y="3694491"/>
+              <a:ext cx="1597819" cy="1748724"/>
+            </a:xfrm>
+            <a:prstGeom prst="rect">
+              <a:avLst/>
+            </a:prstGeom>
+          </p:spPr>
+        </p:pic>
+        <p:sp>
+          <p:nvSpPr>
+            <p:cNvPr id="19" name="TextBox 18">
+              <a:extLst>
+                <a:ext uri="{FF2B5EF4-FFF2-40B4-BE49-F238E27FC236}">
+                  <a16:creationId xmlns:a16="http://schemas.microsoft.com/office/drawing/2014/main" id="{AFFC8068-78E4-1667-9E47-AABEFD549D9B}"/>
+                </a:ext>
+              </a:extLst>
+            </p:cNvPr>
+            <p:cNvSpPr txBox="1"/>
+            <p:nvPr/>
+          </p:nvSpPr>
+          <p:spPr>
+            <a:xfrm>
+              <a:off x="6982931" y="5562600"/>
+              <a:ext cx="1685208" cy="369332"/>
+            </a:xfrm>
+            <a:prstGeom prst="rect">
+              <a:avLst/>
+            </a:prstGeom>
+            <a:noFill/>
+          </p:spPr>
+          <p:txBody>
+            <a:bodyPr wrap="square" rtlCol="0">
+              <a:spAutoFit/>
+            </a:bodyPr>
+            <a:lstStyle/>
+            <a:p>
+              <a:pPr algn="ctr"/>
+              <a:r>
+                <a:rPr lang="en-CA" dirty="0"/>
+                <a:t>Granola bar</a:t>
+              </a:r>
+            </a:p>
+          </p:txBody>
+        </p:sp>
+      </p:grpSp>
+      <p:grpSp>
+        <p:nvGrpSpPr>
+          <p:cNvPr id="26" name="Group 25">
+            <a:extLst>
+              <a:ext uri="{FF2B5EF4-FFF2-40B4-BE49-F238E27FC236}">
+                <a16:creationId xmlns:a16="http://schemas.microsoft.com/office/drawing/2014/main" id="{95A848EB-1384-5D5B-37A4-AE4817A1E7AB}"/>
+              </a:ext>
+            </a:extLst>
+          </p:cNvPr>
+          <p:cNvGrpSpPr/>
+          <p:nvPr/>
+        </p:nvGrpSpPr>
+        <p:grpSpPr>
+          <a:xfrm>
+            <a:off x="6096000" y="3570813"/>
+            <a:ext cx="1927559" cy="2295528"/>
+            <a:chOff x="6096000" y="3570813"/>
+            <a:chExt cx="1927559" cy="2295528"/>
+          </a:xfrm>
+        </p:grpSpPr>
+        <p:pic>
+          <p:nvPicPr>
+            <p:cNvPr id="20" name="Picture 19">
+              <a:extLst>
+                <a:ext uri="{FF2B5EF4-FFF2-40B4-BE49-F238E27FC236}">
+                  <a16:creationId xmlns:a16="http://schemas.microsoft.com/office/drawing/2014/main" id="{304C8595-DBB9-31FE-9B50-892E2B0E7813}"/>
+                </a:ext>
+              </a:extLst>
+            </p:cNvPr>
+            <p:cNvPicPr>
+              <a:picLocks noChangeAspect="1"/>
+            </p:cNvPicPr>
+            <p:nvPr/>
+          </p:nvPicPr>
+          <p:blipFill>
+            <a:blip r:embed="rId7" cstate="print">
+              <a:extLst>
+                <a:ext uri="{28A0092B-C50C-407E-A947-70E740481C1C}">
+                  <a14:useLocalDpi xmlns:a14="http://schemas.microsoft.com/office/drawing/2010/main" val="0"/>
+                </a:ext>
+              </a:extLst>
+            </a:blip>
+            <a:stretch>
+              <a:fillRect/>
+            </a:stretch>
+          </p:blipFill>
+          <p:spPr>
+            <a:xfrm>
+              <a:off x="6226379" y="3570813"/>
+              <a:ext cx="1666800" cy="1666800"/>
+            </a:xfrm>
+            <a:prstGeom prst="rect">
+              <a:avLst/>
+            </a:prstGeom>
+          </p:spPr>
+        </p:pic>
+        <p:sp>
+          <p:nvSpPr>
+            <p:cNvPr id="21" name="TextBox 20">
+              <a:extLst>
+                <a:ext uri="{FF2B5EF4-FFF2-40B4-BE49-F238E27FC236}">
+                  <a16:creationId xmlns:a16="http://schemas.microsoft.com/office/drawing/2014/main" id="{0673A1DB-2D13-764B-0770-A4F5F876EDE2}"/>
+                </a:ext>
+              </a:extLst>
+            </p:cNvPr>
+            <p:cNvSpPr txBox="1"/>
+            <p:nvPr/>
+          </p:nvSpPr>
+          <p:spPr>
+            <a:xfrm>
+              <a:off x="6096000" y="5497009"/>
+              <a:ext cx="1927559" cy="369332"/>
+            </a:xfrm>
+            <a:prstGeom prst="rect">
+              <a:avLst/>
+            </a:prstGeom>
+            <a:noFill/>
+          </p:spPr>
+          <p:txBody>
+            <a:bodyPr wrap="square" rtlCol="0">
+              <a:spAutoFit/>
+            </a:bodyPr>
+            <a:lstStyle/>
+            <a:p>
+              <a:pPr algn="ctr"/>
+              <a:r>
+                <a:rPr lang="en-CA" dirty="0"/>
+                <a:t>Shrimp star charts</a:t>
+              </a:r>
+            </a:p>
+          </p:txBody>
+        </p:sp>
+      </p:grpSp>
+      <p:sp>
+        <p:nvSpPr>
+          <p:cNvPr id="22" name="TextBox 21">
+            <a:extLst>
+              <a:ext uri="{FF2B5EF4-FFF2-40B4-BE49-F238E27FC236}">
+                <a16:creationId xmlns:a16="http://schemas.microsoft.com/office/drawing/2014/main" id="{E568B106-D220-CDD2-B49D-D27A6C163BED}"/>
+              </a:ext>
+            </a:extLst>
+          </p:cNvPr>
+          <p:cNvSpPr txBox="1"/>
+          <p:nvPr/>
+        </p:nvSpPr>
+        <p:spPr>
+          <a:xfrm>
+            <a:off x="609600" y="6096000"/>
+            <a:ext cx="7772400" cy="369332"/>
+          </a:xfrm>
+          <a:prstGeom prst="rect">
+            <a:avLst/>
+          </a:prstGeom>
+          <a:noFill/>
+        </p:spPr>
+        <p:txBody>
+          <a:bodyPr wrap="square" rtlCol="0">
+            <a:spAutoFit/>
+          </a:bodyPr>
+          <a:lstStyle/>
+          <a:p>
+            <a:r>
+              <a:rPr lang="en-CA" dirty="0"/>
+              <a:t>n = 100 trials for each species</a:t>
+            </a:r>
+          </a:p>
+        </p:txBody>
+      </p:sp>
+    </p:spTree>
+    <p:extLst>
+      <p:ext uri="{BB962C8B-B14F-4D97-AF65-F5344CB8AC3E}">
+        <p14:creationId xmlns:p14="http://schemas.microsoft.com/office/powerpoint/2010/main" val="2867764385"/>
+      </p:ext>
+    </p:extLst>
+  </p:cSld>
+  <p:clrMapOvr>
+    <a:masterClrMapping/>
+  </p:clrMapOvr>
+  <p:timing>
+    <p:tnLst>
+      <p:par>
+        <p:cTn id="1" dur="indefinite" restart="never" nodeType="tmRoot">
+          <p:childTnLst>
+            <p:seq concurrent="1" nextAc="seek">
+              <p:cTn id="2" dur="indefinite" nodeType="mainSeq">
+                <p:childTnLst>
+                  <p:par>
+                    <p:cTn id="3" fill="hold">
+                      <p:stCondLst>
+                        <p:cond delay="indefinite"/>
+                      </p:stCondLst>
+                      <p:childTnLst>
+                        <p:par>
+                          <p:cTn id="4" fill="hold">
+                            <p:stCondLst>
+                              <p:cond delay="0"/>
+                            </p:stCondLst>
+                            <p:childTnLst>
+                              <p:par>
+                                <p:cTn id="5" presetID="1" presetClass="entr" presetSubtype="0" fill="hold" nodeType="clickEffect">
+                                  <p:stCondLst>
+                                    <p:cond delay="0"/>
+                                  </p:stCondLst>
+                                  <p:childTnLst>
+                                    <p:set>
+                                      <p:cBhvr>
+                                        <p:cTn id="6" dur="1" fill="hold">
+                                          <p:stCondLst>
+                                            <p:cond delay="0"/>
+                                          </p:stCondLst>
+                                        </p:cTn>
+                                        <p:tgtEl>
+                                          <p:spTgt spid="14"/>
+                                        </p:tgtEl>
+                                        <p:attrNameLst>
+                                          <p:attrName>style.visibility</p:attrName>
+                                        </p:attrNameLst>
+                                      </p:cBhvr>
+                                      <p:to>
+                                        <p:strVal val="visible"/>
+                                      </p:to>
+                                    </p:set>
+                                  </p:childTnLst>
+                                </p:cTn>
+                              </p:par>
+                              <p:par>
+                                <p:cTn id="7" presetID="1" presetClass="entr" presetSubtype="0" fill="hold" nodeType="withEffect">
+                                  <p:stCondLst>
+                                    <p:cond delay="0"/>
+                                  </p:stCondLst>
+                                  <p:childTnLst>
+                                    <p:set>
+                                      <p:cBhvr>
+                                        <p:cTn id="8" dur="1" fill="hold">
+                                          <p:stCondLst>
+                                            <p:cond delay="0"/>
+                                          </p:stCondLst>
+                                        </p:cTn>
+                                        <p:tgtEl>
+                                          <p:spTgt spid="17"/>
+                                        </p:tgtEl>
+                                        <p:attrNameLst>
+                                          <p:attrName>style.visibility</p:attrName>
+                                        </p:attrNameLst>
+                                      </p:cBhvr>
+                                      <p:to>
+                                        <p:strVal val="visible"/>
+                                      </p:to>
+                                    </p:set>
+                                  </p:childTnLst>
+                                </p:cTn>
+                              </p:par>
+                              <p:par>
+                                <p:cTn id="9" presetID="1" presetClass="entr" presetSubtype="0" fill="hold" grpId="0" nodeType="withEffect">
+                                  <p:stCondLst>
+                                    <p:cond delay="0"/>
+                                  </p:stCondLst>
+                                  <p:childTnLst>
+                                    <p:set>
+                                      <p:cBhvr>
+                                        <p:cTn id="10" dur="1" fill="hold">
+                                          <p:stCondLst>
+                                            <p:cond delay="0"/>
+                                          </p:stCondLst>
+                                        </p:cTn>
+                                        <p:tgtEl>
+                                          <p:spTgt spid="10"/>
+                                        </p:tgtEl>
+                                        <p:attrNameLst>
+                                          <p:attrName>style.visibility</p:attrName>
+                                        </p:attrNameLst>
+                                      </p:cBhvr>
+                                      <p:to>
+                                        <p:strVal val="visible"/>
+                                      </p:to>
+                                    </p:set>
+                                  </p:childTnLst>
+                                </p:cTn>
+                              </p:par>
+                              <p:par>
+                                <p:cTn id="11" presetID="1" presetClass="entr" presetSubtype="0" fill="hold" nodeType="withEffect">
+                                  <p:stCondLst>
+                                    <p:cond delay="0"/>
+                                  </p:stCondLst>
+                                  <p:childTnLst>
+                                    <p:set>
+                                      <p:cBhvr>
+                                        <p:cTn id="12" dur="1" fill="hold">
+                                          <p:stCondLst>
+                                            <p:cond delay="0"/>
+                                          </p:stCondLst>
+                                        </p:cTn>
+                                        <p:tgtEl>
+                                          <p:spTgt spid="26"/>
+                                        </p:tgtEl>
+                                        <p:attrNameLst>
+                                          <p:attrName>style.visibility</p:attrName>
+                                        </p:attrNameLst>
+                                      </p:cBhvr>
+                                      <p:to>
+                                        <p:strVal val="visible"/>
+                                      </p:to>
+                                    </p:set>
+                                  </p:childTnLst>
+                                </p:cTn>
+                              </p:par>
+                            </p:childTnLst>
+                          </p:cTn>
+                        </p:par>
+                      </p:childTnLst>
+                    </p:cTn>
+                  </p:par>
+                </p:childTnLst>
+              </p:cTn>
+              <p:prevCondLst>
+                <p:cond evt="onPrev" delay="0">
+                  <p:tgtEl>
+                    <p:sldTgt/>
+                  </p:tgtEl>
+                </p:cond>
+              </p:prevCondLst>
+              <p:nextCondLst>
+                <p:cond evt="onNext" delay="0">
+                  <p:tgtEl>
+                    <p:sldTgt/>
+                  </p:tgtEl>
+                </p:cond>
+              </p:nextCondLst>
+            </p:seq>
+          </p:childTnLst>
+        </p:cTn>
+      </p:par>
+    </p:tnLst>
+    <p:bldLst>
+      <p:bldP spid="10" grpId="0"/>
+    </p:bldLst>
+  </p:timing>
+</p:sld>
+</file>
+
+<file path=ppt/slides/slide15.xml><?xml version="1.0" encoding="utf-8"?>
+<p:sld xmlns:a="http://schemas.openxmlformats.org/drawingml/2006/main" xmlns:r="http://schemas.openxmlformats.org/officeDocument/2006/relationships" xmlns:p="http://schemas.openxmlformats.org/presentationml/2006/main">
+  <p:cSld>
+    <p:spTree>
+      <p:nvGrpSpPr>
+        <p:cNvPr id="1" name=""/>
+        <p:cNvGrpSpPr/>
+        <p:nvPr/>
+      </p:nvGrpSpPr>
+      <p:grpSpPr>
+        <a:xfrm>
+          <a:off x="0" y="0"/>
+          <a:ext cx="0" cy="0"/>
+          <a:chOff x="0" y="0"/>
+          <a:chExt cx="0" cy="0"/>
+        </a:xfrm>
+      </p:grpSpPr>
+      <p:sp>
+        <p:nvSpPr>
+          <p:cNvPr id="2" name="Title 1">
+            <a:extLst>
+              <a:ext uri="{FF2B5EF4-FFF2-40B4-BE49-F238E27FC236}">
+                <a16:creationId xmlns:a16="http://schemas.microsoft.com/office/drawing/2014/main" id="{79FB46FA-DF8D-2EC7-DD00-B848AF54EE8C}"/>
+              </a:ext>
+            </a:extLst>
+          </p:cNvPr>
+          <p:cNvSpPr>
+            <a:spLocks noGrp="1"/>
+          </p:cNvSpPr>
+          <p:nvPr>
+            <p:ph type="title"/>
+          </p:nvPr>
+        </p:nvSpPr>
+        <p:spPr/>
+        <p:txBody>
+          <a:bodyPr>
+            <a:normAutofit fontScale="90000"/>
+          </a:bodyPr>
+          <a:lstStyle/>
+          <a:p>
+            <a:r>
+              <a:rPr lang="en-CA" dirty="0"/>
+              <a:t>Antigua experiment: Results</a:t>
+            </a:r>
+          </a:p>
+        </p:txBody>
+      </p:sp>
+      <p:sp>
+        <p:nvSpPr>
+          <p:cNvPr id="3" name="Slide Number Placeholder 2">
+            <a:extLst>
+              <a:ext uri="{FF2B5EF4-FFF2-40B4-BE49-F238E27FC236}">
+                <a16:creationId xmlns:a16="http://schemas.microsoft.com/office/drawing/2014/main" id="{6B245011-C0C2-6092-DF37-DB68821A94AE}"/>
+              </a:ext>
+            </a:extLst>
+          </p:cNvPr>
+          <p:cNvSpPr>
+            <a:spLocks noGrp="1"/>
+          </p:cNvSpPr>
+          <p:nvPr>
+            <p:ph type="sldNum" sz="quarter" idx="12"/>
+          </p:nvPr>
+        </p:nvSpPr>
+        <p:spPr/>
+        <p:txBody>
+          <a:bodyPr/>
+          <a:lstStyle/>
+          <a:p>
+            <a:fld id="{621225AB-15B9-4C79-A121-04D1DC7E2307}" type="slidenum">
+              <a:rPr lang="en-US" smtClean="0"/>
+              <a:t>15</a:t>
+            </a:fld>
+            <a:endParaRPr lang="en-US"/>
+          </a:p>
+        </p:txBody>
+      </p:sp>
+      <p:sp>
+        <p:nvSpPr>
+          <p:cNvPr id="4" name="TextBox 3">
+            <a:extLst>
+              <a:ext uri="{FF2B5EF4-FFF2-40B4-BE49-F238E27FC236}">
+                <a16:creationId xmlns:a16="http://schemas.microsoft.com/office/drawing/2014/main" id="{ACC67093-352C-7864-3897-7FF8244CE3E8}"/>
+              </a:ext>
+            </a:extLst>
+          </p:cNvPr>
+          <p:cNvSpPr txBox="1"/>
+          <p:nvPr/>
+        </p:nvSpPr>
+        <p:spPr>
+          <a:xfrm>
+            <a:off x="457200" y="1219200"/>
+            <a:ext cx="5715000" cy="1600438"/>
+          </a:xfrm>
+          <a:prstGeom prst="rect">
+            <a:avLst/>
+          </a:prstGeom>
+          <a:solidFill>
+            <a:schemeClr val="accent6">
+              <a:lumMod val="20000"/>
+              <a:lumOff val="80000"/>
+              <a:alpha val="50000"/>
+            </a:schemeClr>
+          </a:solidFill>
+        </p:spPr>
+        <p:txBody>
+          <a:bodyPr wrap="square" rtlCol="0">
+            <a:spAutoFit/>
+          </a:bodyPr>
+          <a:lstStyle/>
+          <a:p>
+            <a:pPr latinLnBrk="1"/>
+            <a:r>
+              <a:rPr lang="en-CA" sz="1400" dirty="0">
+                <a:latin typeface="Aptos Mono" panose="020B0009020202020204" pitchFamily="49" charset="0"/>
+              </a:rPr>
+              <a:t>&gt; </a:t>
+            </a:r>
+            <a:r>
+              <a:rPr lang="en-CA" sz="1400" dirty="0" err="1">
+                <a:latin typeface="Aptos Mono" panose="020B0009020202020204" pitchFamily="49" charset="0"/>
+              </a:rPr>
+              <a:t>addmargins</a:t>
+            </a:r>
+            <a:r>
+              <a:rPr lang="en-CA" sz="1400" dirty="0">
+                <a:latin typeface="Aptos Mono" panose="020B0009020202020204" pitchFamily="49" charset="0"/>
+              </a:rPr>
+              <a:t>(</a:t>
+            </a:r>
+            <a:r>
+              <a:rPr lang="en-CA" sz="1400" dirty="0" err="1">
+                <a:latin typeface="Aptos Mono" panose="020B0009020202020204" pitchFamily="49" charset="0"/>
+              </a:rPr>
+              <a:t>freq</a:t>
+            </a:r>
+            <a:r>
+              <a:rPr lang="en-CA" sz="1400" dirty="0">
+                <a:latin typeface="Aptos Mono" panose="020B0009020202020204" pitchFamily="49" charset="0"/>
+              </a:rPr>
+              <a:t>)</a:t>
+            </a:r>
+          </a:p>
+          <a:p>
+            <a:pPr latinLnBrk="1"/>
+            <a:r>
+              <a:rPr lang="en-CA" sz="1400" dirty="0">
+                <a:latin typeface="Aptos Mono" panose="020B0009020202020204" pitchFamily="49" charset="0"/>
+              </a:rPr>
+              <a:t>          Stimulus</a:t>
+            </a:r>
+          </a:p>
+          <a:p>
+            <a:pPr latinLnBrk="1"/>
+            <a:r>
+              <a:rPr lang="en-CA" sz="1400" dirty="0">
+                <a:latin typeface="Aptos Mono" panose="020B0009020202020204" pitchFamily="49" charset="0"/>
+              </a:rPr>
+              <a:t>Species    Conch Pie Granola Bar Shrimp Star Sum</a:t>
+            </a:r>
+          </a:p>
+          <a:p>
+            <a:pPr latinLnBrk="1"/>
+            <a:r>
+              <a:rPr lang="en-CA" sz="1400" dirty="0">
+                <a:latin typeface="Aptos Mono" panose="020B0009020202020204" pitchFamily="49" charset="0"/>
+              </a:rPr>
+              <a:t>  Shark           60          25          15 100</a:t>
+            </a:r>
+          </a:p>
+          <a:p>
+            <a:pPr latinLnBrk="1"/>
+            <a:r>
+              <a:rPr lang="en-CA" sz="1400" dirty="0">
+                <a:latin typeface="Aptos Mono" panose="020B0009020202020204" pitchFamily="49" charset="0"/>
+              </a:rPr>
+              <a:t>  Turtle          15          70          15 100</a:t>
+            </a:r>
+          </a:p>
+          <a:p>
+            <a:pPr latinLnBrk="1"/>
+            <a:r>
+              <a:rPr lang="en-CA" sz="1400" dirty="0">
+                <a:latin typeface="Aptos Mono" panose="020B0009020202020204" pitchFamily="49" charset="0"/>
+              </a:rPr>
+              <a:t>  </a:t>
+            </a:r>
+            <a:r>
+              <a:rPr lang="en-CA" sz="1400" dirty="0" err="1">
+                <a:latin typeface="Aptos Mono" panose="020B0009020202020204" pitchFamily="49" charset="0"/>
+              </a:rPr>
+              <a:t>StingRay</a:t>
+            </a:r>
+            <a:r>
+              <a:rPr lang="en-CA" sz="1400" dirty="0">
+                <a:latin typeface="Aptos Mono" panose="020B0009020202020204" pitchFamily="49" charset="0"/>
+              </a:rPr>
+              <a:t>        22          18          60 100</a:t>
+            </a:r>
+          </a:p>
+          <a:p>
+            <a:pPr latinLnBrk="1"/>
+            <a:r>
+              <a:rPr lang="en-CA" sz="1400" dirty="0">
+                <a:latin typeface="Aptos Mono" panose="020B0009020202020204" pitchFamily="49" charset="0"/>
+              </a:rPr>
+              <a:t>  Sum             97         113          90 300</a:t>
+            </a:r>
+          </a:p>
+        </p:txBody>
+      </p:sp>
+      <p:grpSp>
+        <p:nvGrpSpPr>
+          <p:cNvPr id="11" name="Group 10">
+            <a:extLst>
+              <a:ext uri="{FF2B5EF4-FFF2-40B4-BE49-F238E27FC236}">
+                <a16:creationId xmlns:a16="http://schemas.microsoft.com/office/drawing/2014/main" id="{C8808A90-43B2-C14F-3B23-20FF8BA41F0E}"/>
+              </a:ext>
+            </a:extLst>
+          </p:cNvPr>
+          <p:cNvGrpSpPr/>
+          <p:nvPr/>
+        </p:nvGrpSpPr>
+        <p:grpSpPr>
+          <a:xfrm>
+            <a:off x="533400" y="3017719"/>
+            <a:ext cx="3429001" cy="3545978"/>
+            <a:chOff x="533400" y="3017719"/>
+            <a:chExt cx="3429001" cy="3545978"/>
+          </a:xfrm>
+        </p:grpSpPr>
+        <p:pic>
+          <p:nvPicPr>
+            <p:cNvPr id="6" name="Picture 5">
+              <a:extLst>
+                <a:ext uri="{FF2B5EF4-FFF2-40B4-BE49-F238E27FC236}">
+                  <a16:creationId xmlns:a16="http://schemas.microsoft.com/office/drawing/2014/main" id="{EB538610-2969-06F0-3D78-AE86EDFE3F59}"/>
+                </a:ext>
+              </a:extLst>
+            </p:cNvPr>
+            <p:cNvPicPr>
+              <a:picLocks noChangeAspect="1"/>
+            </p:cNvPicPr>
+            <p:nvPr/>
+          </p:nvPicPr>
+          <p:blipFill>
+            <a:blip r:embed="rId2"/>
+            <a:stretch>
+              <a:fillRect/>
+            </a:stretch>
+          </p:blipFill>
+          <p:spPr>
+            <a:xfrm>
+              <a:off x="533400" y="3501467"/>
+              <a:ext cx="3023952" cy="3062230"/>
+            </a:xfrm>
+            <a:prstGeom prst="rect">
+              <a:avLst/>
+            </a:prstGeom>
+          </p:spPr>
+        </p:pic>
+        <p:sp>
+          <p:nvSpPr>
+            <p:cNvPr id="9" name="TextBox 8">
+              <a:extLst>
+                <a:ext uri="{FF2B5EF4-FFF2-40B4-BE49-F238E27FC236}">
+                  <a16:creationId xmlns:a16="http://schemas.microsoft.com/office/drawing/2014/main" id="{1C7C8E17-056E-8A04-98B3-ACD9A967BD2A}"/>
+                </a:ext>
+              </a:extLst>
+            </p:cNvPr>
+            <p:cNvSpPr txBox="1"/>
+            <p:nvPr/>
+          </p:nvSpPr>
+          <p:spPr>
+            <a:xfrm>
+              <a:off x="533400" y="3017719"/>
+              <a:ext cx="3429001" cy="369332"/>
+            </a:xfrm>
+            <a:prstGeom prst="rect">
+              <a:avLst/>
+            </a:prstGeom>
+            <a:solidFill>
+              <a:schemeClr val="accent6">
+                <a:lumMod val="20000"/>
+                <a:lumOff val="80000"/>
+                <a:alpha val="50000"/>
+              </a:schemeClr>
+            </a:solidFill>
+          </p:spPr>
+          <p:txBody>
+            <a:bodyPr wrap="square" rtlCol="0">
+              <a:spAutoFit/>
+            </a:bodyPr>
+            <a:lstStyle/>
+            <a:p>
+              <a:r>
+                <a:rPr lang="en-CA" dirty="0">
+                  <a:latin typeface="Aptos Mono" panose="020B0009020202020204" pitchFamily="49" charset="0"/>
+                </a:rPr>
+                <a:t>mosaic(</a:t>
+              </a:r>
+              <a:r>
+                <a:rPr lang="en-CA" dirty="0" err="1">
+                  <a:latin typeface="Aptos Mono" panose="020B0009020202020204" pitchFamily="49" charset="0"/>
+                </a:rPr>
+                <a:t>freq</a:t>
+              </a:r>
+              <a:r>
+                <a:rPr lang="en-CA" dirty="0">
+                  <a:latin typeface="Aptos Mono" panose="020B0009020202020204" pitchFamily="49" charset="0"/>
+                </a:rPr>
+                <a:t>)</a:t>
+              </a:r>
+            </a:p>
+          </p:txBody>
+        </p:sp>
+      </p:grpSp>
+      <p:grpSp>
+        <p:nvGrpSpPr>
+          <p:cNvPr id="12" name="Group 11">
+            <a:extLst>
+              <a:ext uri="{FF2B5EF4-FFF2-40B4-BE49-F238E27FC236}">
+                <a16:creationId xmlns:a16="http://schemas.microsoft.com/office/drawing/2014/main" id="{F16B1EB7-3224-0C62-766F-722F9094B603}"/>
+              </a:ext>
+            </a:extLst>
+          </p:cNvPr>
+          <p:cNvGrpSpPr/>
+          <p:nvPr/>
+        </p:nvGrpSpPr>
+        <p:grpSpPr>
+          <a:xfrm>
+            <a:off x="4343400" y="3017719"/>
+            <a:ext cx="3962400" cy="3695104"/>
+            <a:chOff x="4343400" y="3017719"/>
+            <a:chExt cx="3962400" cy="3695104"/>
+          </a:xfrm>
+        </p:grpSpPr>
+        <p:pic>
+          <p:nvPicPr>
+            <p:cNvPr id="8" name="Picture 7">
+              <a:extLst>
+                <a:ext uri="{FF2B5EF4-FFF2-40B4-BE49-F238E27FC236}">
+                  <a16:creationId xmlns:a16="http://schemas.microsoft.com/office/drawing/2014/main" id="{675F0254-3608-5635-172D-CD3E0782EEA9}"/>
+                </a:ext>
+              </a:extLst>
+            </p:cNvPr>
+            <p:cNvPicPr>
+              <a:picLocks noChangeAspect="1"/>
+            </p:cNvPicPr>
+            <p:nvPr/>
+          </p:nvPicPr>
+          <p:blipFill>
+            <a:blip r:embed="rId3"/>
+            <a:stretch>
+              <a:fillRect/>
+            </a:stretch>
+          </p:blipFill>
+          <p:spPr>
+            <a:xfrm>
+              <a:off x="4343400" y="3501467"/>
+              <a:ext cx="3962400" cy="3211356"/>
+            </a:xfrm>
+            <a:prstGeom prst="rect">
+              <a:avLst/>
+            </a:prstGeom>
+          </p:spPr>
+        </p:pic>
+        <p:sp>
+          <p:nvSpPr>
+            <p:cNvPr id="10" name="TextBox 9">
+              <a:extLst>
+                <a:ext uri="{FF2B5EF4-FFF2-40B4-BE49-F238E27FC236}">
+                  <a16:creationId xmlns:a16="http://schemas.microsoft.com/office/drawing/2014/main" id="{196CC668-A0BB-B40C-2BCE-09EE9FDB9CBA}"/>
+                </a:ext>
+              </a:extLst>
+            </p:cNvPr>
+            <p:cNvSpPr txBox="1"/>
+            <p:nvPr/>
+          </p:nvSpPr>
+          <p:spPr>
+            <a:xfrm>
+              <a:off x="4343400" y="3017719"/>
+              <a:ext cx="3851787" cy="369332"/>
+            </a:xfrm>
+            <a:prstGeom prst="rect">
+              <a:avLst/>
+            </a:prstGeom>
+            <a:solidFill>
+              <a:schemeClr val="accent6">
+                <a:lumMod val="20000"/>
+                <a:lumOff val="80000"/>
+                <a:alpha val="50000"/>
+              </a:schemeClr>
+            </a:solidFill>
+          </p:spPr>
+          <p:txBody>
+            <a:bodyPr wrap="square" rtlCol="0">
+              <a:spAutoFit/>
+            </a:bodyPr>
+            <a:lstStyle/>
+            <a:p>
+              <a:r>
+                <a:rPr lang="en-CA" dirty="0">
+                  <a:latin typeface="Aptos Mono" panose="020B0009020202020204" pitchFamily="49" charset="0"/>
+                </a:rPr>
+                <a:t>ca(</a:t>
+              </a:r>
+              <a:r>
+                <a:rPr lang="en-CA" dirty="0" err="1">
+                  <a:latin typeface="Aptos Mono" panose="020B0009020202020204" pitchFamily="49" charset="0"/>
+                </a:rPr>
+                <a:t>freq</a:t>
+              </a:r>
+              <a:r>
+                <a:rPr lang="en-CA" dirty="0">
+                  <a:latin typeface="Aptos Mono" panose="020B0009020202020204" pitchFamily="49" charset="0"/>
+                </a:rPr>
+                <a:t>)|&gt; plot()</a:t>
+              </a:r>
+            </a:p>
+          </p:txBody>
+        </p:sp>
+      </p:grpSp>
+    </p:spTree>
+    <p:extLst>
+      <p:ext uri="{BB962C8B-B14F-4D97-AF65-F5344CB8AC3E}">
+        <p14:creationId xmlns:p14="http://schemas.microsoft.com/office/powerpoint/2010/main" val="861849817"/>
+      </p:ext>
+    </p:extLst>
+  </p:cSld>
+  <p:clrMapOvr>
+    <a:masterClrMapping/>
+  </p:clrMapOvr>
+  <p:timing>
+    <p:tnLst>
+      <p:par>
+        <p:cTn id="1" dur="indefinite" restart="never" nodeType="tmRoot">
+          <p:childTnLst>
+            <p:seq concurrent="1" nextAc="seek">
+              <p:cTn id="2" dur="indefinite" nodeType="mainSeq">
+                <p:childTnLst>
+                  <p:par>
+                    <p:cTn id="3" fill="hold">
+                      <p:stCondLst>
+                        <p:cond delay="indefinite"/>
+                      </p:stCondLst>
+                      <p:childTnLst>
+                        <p:par>
+                          <p:cTn id="4" fill="hold">
+                            <p:stCondLst>
+                              <p:cond delay="0"/>
+                            </p:stCondLst>
+                            <p:childTnLst>
+                              <p:par>
+                                <p:cTn id="5" presetID="2" presetClass="entr" presetSubtype="4" fill="hold" nodeType="clickEffect">
+                                  <p:stCondLst>
+                                    <p:cond delay="0"/>
+                                  </p:stCondLst>
+                                  <p:childTnLst>
+                                    <p:set>
+                                      <p:cBhvr>
+                                        <p:cTn id="6" dur="1" fill="hold">
+                                          <p:stCondLst>
+                                            <p:cond delay="0"/>
+                                          </p:stCondLst>
+                                        </p:cTn>
+                                        <p:tgtEl>
+                                          <p:spTgt spid="11"/>
+                                        </p:tgtEl>
+                                        <p:attrNameLst>
+                                          <p:attrName>style.visibility</p:attrName>
+                                        </p:attrNameLst>
+                                      </p:cBhvr>
+                                      <p:to>
+                                        <p:strVal val="visible"/>
+                                      </p:to>
+                                    </p:set>
+                                    <p:anim calcmode="lin" valueType="num">
+                                      <p:cBhvr additive="base">
+                                        <p:cTn id="7" dur="500" fill="hold"/>
+                                        <p:tgtEl>
+                                          <p:spTgt spid="11"/>
+                                        </p:tgtEl>
+                                        <p:attrNameLst>
+                                          <p:attrName>ppt_x</p:attrName>
+                                        </p:attrNameLst>
+                                      </p:cBhvr>
+                                      <p:tavLst>
+                                        <p:tav tm="0">
+                                          <p:val>
+                                            <p:strVal val="#ppt_x"/>
+                                          </p:val>
+                                        </p:tav>
+                                        <p:tav tm="100000">
+                                          <p:val>
+                                            <p:strVal val="#ppt_x"/>
+                                          </p:val>
+                                        </p:tav>
+                                      </p:tavLst>
+                                    </p:anim>
+                                    <p:anim calcmode="lin" valueType="num">
+                                      <p:cBhvr additive="base">
+                                        <p:cTn id="8" dur="500" fill="hold"/>
+                                        <p:tgtEl>
+                                          <p:spTgt spid="11"/>
+                                        </p:tgtEl>
+                                        <p:attrNameLst>
+                                          <p:attrName>ppt_y</p:attrName>
+                                        </p:attrNameLst>
+                                      </p:cBhvr>
+                                      <p:tavLst>
+                                        <p:tav tm="0">
+                                          <p:val>
+                                            <p:strVal val="1+#ppt_h/2"/>
+                                          </p:val>
+                                        </p:tav>
+                                        <p:tav tm="100000">
+                                          <p:val>
+                                            <p:strVal val="#ppt_y"/>
+                                          </p:val>
+                                        </p:tav>
+                                      </p:tavLst>
+                                    </p:anim>
+                                  </p:childTnLst>
+                                </p:cTn>
+                              </p:par>
+                            </p:childTnLst>
+                          </p:cTn>
+                        </p:par>
+                      </p:childTnLst>
+                    </p:cTn>
+                  </p:par>
+                  <p:par>
+                    <p:cTn id="9" fill="hold">
+                      <p:stCondLst>
+                        <p:cond delay="indefinite"/>
+                      </p:stCondLst>
+                      <p:childTnLst>
+                        <p:par>
+                          <p:cTn id="10" fill="hold">
+                            <p:stCondLst>
+                              <p:cond delay="0"/>
+                            </p:stCondLst>
+                            <p:childTnLst>
+                              <p:par>
+                                <p:cTn id="11" presetID="2" presetClass="entr" presetSubtype="4" fill="hold" nodeType="clickEffect">
+                                  <p:stCondLst>
+                                    <p:cond delay="0"/>
+                                  </p:stCondLst>
+                                  <p:childTnLst>
+                                    <p:set>
+                                      <p:cBhvr>
+                                        <p:cTn id="12" dur="1" fill="hold">
+                                          <p:stCondLst>
+                                            <p:cond delay="0"/>
+                                          </p:stCondLst>
+                                        </p:cTn>
+                                        <p:tgtEl>
+                                          <p:spTgt spid="12"/>
+                                        </p:tgtEl>
+                                        <p:attrNameLst>
+                                          <p:attrName>style.visibility</p:attrName>
+                                        </p:attrNameLst>
+                                      </p:cBhvr>
+                                      <p:to>
+                                        <p:strVal val="visible"/>
+                                      </p:to>
+                                    </p:set>
+                                    <p:anim calcmode="lin" valueType="num">
+                                      <p:cBhvr additive="base">
+                                        <p:cTn id="13" dur="500" fill="hold"/>
+                                        <p:tgtEl>
+                                          <p:spTgt spid="12"/>
+                                        </p:tgtEl>
+                                        <p:attrNameLst>
+                                          <p:attrName>ppt_x</p:attrName>
+                                        </p:attrNameLst>
+                                      </p:cBhvr>
+                                      <p:tavLst>
+                                        <p:tav tm="0">
+                                          <p:val>
+                                            <p:strVal val="#ppt_x"/>
+                                          </p:val>
+                                        </p:tav>
+                                        <p:tav tm="100000">
+                                          <p:val>
+                                            <p:strVal val="#ppt_x"/>
+                                          </p:val>
+                                        </p:tav>
+                                      </p:tavLst>
+                                    </p:anim>
+                                    <p:anim calcmode="lin" valueType="num">
+                                      <p:cBhvr additive="base">
+                                        <p:cTn id="14" dur="500" fill="hold"/>
+                                        <p:tgtEl>
+                                          <p:spTgt spid="12"/>
+                                        </p:tgtEl>
+                                        <p:attrNameLst>
+                                          <p:attrName>ppt_y</p:attrName>
+                                        </p:attrNameLst>
+                                      </p:cBhvr>
+                                      <p:tavLst>
+                                        <p:tav tm="0">
+                                          <p:val>
+                                            <p:strVal val="1+#ppt_h/2"/>
+                                          </p:val>
+                                        </p:tav>
+                                        <p:tav tm="100000">
+                                          <p:val>
+                                            <p:strVal val="#ppt_y"/>
+                                          </p:val>
+                                        </p:tav>
+                                      </p:tavLst>
+                                    </p:anim>
+                                  </p:childTnLst>
+                                </p:cTn>
+                              </p:par>
+                            </p:childTnLst>
+                          </p:cTn>
+                        </p:par>
+                      </p:childTnLst>
+                    </p:cTn>
+                  </p:par>
+                </p:childTnLst>
+              </p:cTn>
+              <p:prevCondLst>
+                <p:cond evt="onPrev" delay="0">
+                  <p:tgtEl>
+                    <p:sldTgt/>
+                  </p:tgtEl>
+                </p:cond>
+              </p:prevCondLst>
+              <p:nextCondLst>
+                <p:cond evt="onNext" delay="0">
+                  <p:tgtEl>
+                    <p:sldTgt/>
+                  </p:tgtEl>
+                </p:cond>
+              </p:nextCondLst>
+            </p:seq>
+          </p:childTnLst>
+        </p:cTn>
+      </p:par>
+    </p:tnLst>
+  </p:timing>
+</p:sld>
+</file>
+
+<file path=ppt/slides/slide16.xml><?xml version="1.0" encoding="utf-8"?>
+<p:sld xmlns:a="http://schemas.openxmlformats.org/drawingml/2006/main" xmlns:r="http://schemas.openxmlformats.org/officeDocument/2006/relationships" xmlns:p="http://schemas.openxmlformats.org/presentationml/2006/main">
+  <p:cSld>
+    <p:spTree>
+      <p:nvGrpSpPr>
+        <p:cNvPr id="1" name=""/>
+        <p:cNvGrpSpPr/>
+        <p:nvPr/>
+      </p:nvGrpSpPr>
+      <p:grpSpPr>
+        <a:xfrm>
+          <a:off x="0" y="0"/>
+          <a:ext cx="0" cy="0"/>
+          <a:chOff x="0" y="0"/>
+          <a:chExt cx="0" cy="0"/>
+        </a:xfrm>
+      </p:grpSpPr>
+      <p:sp>
+        <p:nvSpPr>
           <p:cNvPr id="2" name="Title 1"/>
           <p:cNvSpPr>
             <a:spLocks noGrp="1"/>
@@ -5288,7 +7436,7 @@
           <a:p>
             <a:fld id="{621225AB-15B9-4C79-A121-04D1DC7E2307}" type="slidenum">
               <a:rPr lang="en-US" smtClean="0"/>
-              <a:t>13</a:t>
+              <a:t>16</a:t>
             </a:fld>
             <a:endParaRPr lang="en-US"/>
           </a:p>
@@ -6595,7 +8743,7 @@
 </p:sld>
 </file>
 
-<file path=ppt/slides/slide14.xml><?xml version="1.0" encoding="utf-8"?>
+<file path=ppt/slides/slide17.xml><?xml version="1.0" encoding="utf-8"?>
 <p:sld xmlns:a="http://schemas.openxmlformats.org/drawingml/2006/main" xmlns:r="http://schemas.openxmlformats.org/officeDocument/2006/relationships" xmlns:p="http://schemas.openxmlformats.org/presentationml/2006/main">
   <p:cSld>
     <p:bg>
@@ -7472,7 +9620,7 @@
                   <a:spcPts val="600"/>
                 </a:spcAft>
               </a:pPr>
-              <a:t>14</a:t>
+              <a:t>17</a:t>
             </a:fld>
             <a:endParaRPr lang="en-US">
               <a:solidFill>
@@ -7495,7 +9643,7 @@
 </p:sld>
 </file>
 
-<file path=ppt/slides/slide15.xml><?xml version="1.0" encoding="utf-8"?>
+<file path=ppt/slides/slide18.xml><?xml version="1.0" encoding="utf-8"?>
 <p:sld xmlns:a="http://schemas.openxmlformats.org/drawingml/2006/main" xmlns:r="http://schemas.openxmlformats.org/officeDocument/2006/relationships" xmlns:p="http://schemas.openxmlformats.org/presentationml/2006/main">
   <p:cSld>
     <p:bg>
@@ -7827,7 +9975,7 @@
                   <a:spcPts val="600"/>
                 </a:spcAft>
               </a:pPr>
-              <a:t>15</a:t>
+              <a:t>18</a:t>
             </a:fld>
             <a:endParaRPr lang="en-US">
               <a:solidFill>
@@ -7867,12 +10015,91 @@
           </a:prstGeom>
         </p:spPr>
       </p:pic>
+      <p:sp>
+        <p:nvSpPr>
+          <p:cNvPr id="2" name="TextBox 1">
+            <a:extLst>
+              <a:ext uri="{FF2B5EF4-FFF2-40B4-BE49-F238E27FC236}">
+                <a16:creationId xmlns:a16="http://schemas.microsoft.com/office/drawing/2014/main" id="{886E0730-F7C7-158B-AE80-DB4679D2F49F}"/>
+              </a:ext>
+            </a:extLst>
+          </p:cNvPr>
+          <p:cNvSpPr txBox="1"/>
+          <p:nvPr/>
+        </p:nvSpPr>
+        <p:spPr>
+          <a:xfrm>
+            <a:off x="1447800" y="2721114"/>
+            <a:ext cx="2514600" cy="461665"/>
+          </a:xfrm>
+          <a:prstGeom prst="rect">
+            <a:avLst/>
+          </a:prstGeom>
+          <a:noFill/>
+        </p:spPr>
+        <p:txBody>
+          <a:bodyPr wrap="square" rtlCol="0">
+            <a:spAutoFit/>
+          </a:bodyPr>
+          <a:lstStyle/>
+          <a:p>
+            <a:r>
+              <a:rPr lang="en-CA" sz="2400" dirty="0">
+                <a:solidFill>
+                  <a:schemeClr val="bg1"/>
+                </a:solidFill>
+              </a:rPr>
+              <a:t>Nellie Nurse shark</a:t>
+            </a:r>
+          </a:p>
+        </p:txBody>
+      </p:sp>
+      <p:sp>
+        <p:nvSpPr>
+          <p:cNvPr id="3" name="TextBox 2">
+            <a:extLst>
+              <a:ext uri="{FF2B5EF4-FFF2-40B4-BE49-F238E27FC236}">
+                <a16:creationId xmlns:a16="http://schemas.microsoft.com/office/drawing/2014/main" id="{9EB0B321-91C0-44A1-1A1D-1AB11F8FF102}"/>
+              </a:ext>
+            </a:extLst>
+          </p:cNvPr>
+          <p:cNvSpPr txBox="1"/>
+          <p:nvPr/>
+        </p:nvSpPr>
+        <p:spPr>
+          <a:xfrm>
+            <a:off x="5907646" y="4114800"/>
+            <a:ext cx="2893454" cy="461665"/>
+          </a:xfrm>
+          <a:prstGeom prst="rect">
+            <a:avLst/>
+          </a:prstGeom>
+          <a:noFill/>
+        </p:spPr>
+        <p:txBody>
+          <a:bodyPr wrap="square" rtlCol="0">
+            <a:spAutoFit/>
+          </a:bodyPr>
+          <a:lstStyle/>
+          <a:p>
+            <a:pPr algn="ctr"/>
+            <a:r>
+              <a:rPr lang="en-CA" sz="2400" dirty="0">
+                <a:solidFill>
+                  <a:schemeClr val="bg1"/>
+                </a:solidFill>
+              </a:rPr>
+              <a:t>Tommy turtle</a:t>
+            </a:r>
+          </a:p>
+        </p:txBody>
+      </p:sp>
       <p:pic>
         <p:nvPicPr>
-          <p:cNvPr id="11" name="Picture 10" descr="A picture containing text&#10;&#10;Description automatically generated">
+          <p:cNvPr id="7" name="Picture 6">
             <a:extLst>
               <a:ext uri="{FF2B5EF4-FFF2-40B4-BE49-F238E27FC236}">
-                <a16:creationId xmlns:a16="http://schemas.microsoft.com/office/drawing/2014/main" id="{0F29754A-B957-598A-B141-B008E5E21EE3}"/>
+                <a16:creationId xmlns:a16="http://schemas.microsoft.com/office/drawing/2014/main" id="{9B56D0BD-3E1B-DD24-680A-171FFDCCC4D3}"/>
               </a:ext>
             </a:extLst>
           </p:cNvPr>
@@ -7882,21 +10109,15 @@
           <p:nvPr/>
         </p:nvPicPr>
         <p:blipFill>
-          <a:blip r:embed="rId4" cstate="print">
-            <a:extLst>
-              <a:ext uri="{28A0092B-C50C-407E-A947-70E740481C1C}">
-                <a14:useLocalDpi xmlns:a14="http://schemas.microsoft.com/office/drawing/2010/main" val="0"/>
-              </a:ext>
-            </a:extLst>
-          </a:blip>
+          <a:blip r:embed="rId4"/>
           <a:stretch>
             <a:fillRect/>
           </a:stretch>
         </p:blipFill>
         <p:spPr>
           <a:xfrm>
-            <a:off x="4597003" y="2539748"/>
-            <a:ext cx="1310643" cy="853442"/>
+            <a:off x="4597003" y="104604"/>
+            <a:ext cx="1723844" cy="1723844"/>
           </a:xfrm>
           <a:prstGeom prst="rect">
             <a:avLst/>
@@ -7905,10 +10126,10 @@
       </p:pic>
       <p:sp>
         <p:nvSpPr>
-          <p:cNvPr id="2" name="TextBox 1">
+          <p:cNvPr id="12" name="TextBox 11">
             <a:extLst>
               <a:ext uri="{FF2B5EF4-FFF2-40B4-BE49-F238E27FC236}">
-                <a16:creationId xmlns:a16="http://schemas.microsoft.com/office/drawing/2014/main" id="{886E0730-F7C7-158B-AE80-DB4679D2F49F}"/>
+                <a16:creationId xmlns:a16="http://schemas.microsoft.com/office/drawing/2014/main" id="{19FB187B-D696-705A-26E8-B789B84C812C}"/>
               </a:ext>
             </a:extLst>
           </p:cNvPr>
@@ -7917,8 +10138,8 @@
         </p:nvSpPr>
         <p:spPr>
           <a:xfrm>
-            <a:off x="2499357" y="2590800"/>
-            <a:ext cx="1310643" cy="646331"/>
+            <a:off x="4267200" y="990600"/>
+            <a:ext cx="2438400" cy="461665"/>
           </a:xfrm>
           <a:prstGeom prst="rect">
             <a:avLst/>
@@ -7932,22 +10153,22 @@
           <a:lstStyle/>
           <a:p>
             <a:r>
-              <a:rPr lang="en-CA" dirty="0">
+              <a:rPr lang="en-CA" sz="2400" dirty="0">
                 <a:solidFill>
                   <a:schemeClr val="bg1"/>
                 </a:solidFill>
               </a:rPr>
-              <a:t>Nellie the nurse shark</a:t>
-            </a:r>
-          </a:p>
-        </p:txBody>
-      </p:sp>
-      <p:sp>
-        <p:nvSpPr>
-          <p:cNvPr id="3" name="TextBox 2">
+              <a:t>Sammy Sting Ray</a:t>
+            </a:r>
+          </a:p>
+        </p:txBody>
+      </p:sp>
+      <p:sp>
+        <p:nvSpPr>
+          <p:cNvPr id="13" name="TextBox 12">
             <a:extLst>
               <a:ext uri="{FF2B5EF4-FFF2-40B4-BE49-F238E27FC236}">
-                <a16:creationId xmlns:a16="http://schemas.microsoft.com/office/drawing/2014/main" id="{9EB0B321-91C0-44A1-1A1D-1AB11F8FF102}"/>
+                <a16:creationId xmlns:a16="http://schemas.microsoft.com/office/drawing/2014/main" id="{3720D04E-9AF6-8B31-B2F0-5280C891BB10}"/>
               </a:ext>
             </a:extLst>
           </p:cNvPr>
@@ -7956,8 +10177,8 @@
         </p:nvSpPr>
         <p:spPr>
           <a:xfrm>
-            <a:off x="5907646" y="4114800"/>
-            <a:ext cx="1598054" cy="369332"/>
+            <a:off x="7505700" y="1708364"/>
+            <a:ext cx="1295400" cy="461665"/>
           </a:xfrm>
           <a:prstGeom prst="rect">
             <a:avLst/>
@@ -7970,13 +10191,14 @@
           </a:bodyPr>
           <a:lstStyle/>
           <a:p>
-            <a:r>
-              <a:rPr lang="en-CA" dirty="0">
+            <a:pPr algn="ctr"/>
+            <a:r>
+              <a:rPr lang="en-CA" sz="2400" dirty="0">
                 <a:solidFill>
                   <a:schemeClr val="bg1"/>
                 </a:solidFill>
               </a:rPr>
-              <a:t>Tommy turtle</a:t>
+              <a:t>Author</a:t>
             </a:r>
           </a:p>
         </p:txBody>
@@ -7997,20 +10219,6 @@
 <file path=ppt/slides/slide2.xml><?xml version="1.0" encoding="utf-8"?>
 <p:sld xmlns:a="http://schemas.openxmlformats.org/drawingml/2006/main" xmlns:r="http://schemas.openxmlformats.org/officeDocument/2006/relationships" xmlns:p="http://schemas.openxmlformats.org/presentationml/2006/main">
   <p:cSld>
-    <p:bg>
-      <p:bgPr>
-        <a:blipFill dpi="0" rotWithShape="1">
-          <a:blip r:embed="rId2">
-            <a:lum/>
-          </a:blip>
-          <a:srcRect/>
-          <a:stretch>
-            <a:fillRect/>
-          </a:stretch>
-        </a:blipFill>
-        <a:effectLst/>
-      </p:bgPr>
-    </p:bg>
     <p:spTree>
       <p:nvGrpSpPr>
         <p:cNvPr id="1" name=""/>
@@ -8027,7 +10235,13 @@
       </p:grpSpPr>
       <p:sp>
         <p:nvSpPr>
-          <p:cNvPr id="2" name="Slide Number Placeholder 1"/>
+          <p:cNvPr id="2" name="Slide Number Placeholder 1">
+            <a:extLst>
+              <a:ext uri="{FF2B5EF4-FFF2-40B4-BE49-F238E27FC236}">
+                <a16:creationId xmlns:a16="http://schemas.microsoft.com/office/drawing/2014/main" id="{CEFFB502-FB04-5A97-56E3-5988CE92E6C6}"/>
+              </a:ext>
+            </a:extLst>
+          </p:cNvPr>
           <p:cNvSpPr>
             <a:spLocks noGrp="1"/>
           </p:cNvSpPr>
@@ -8048,80 +10262,12 @@
           </a:p>
         </p:txBody>
       </p:sp>
-      <p:sp>
-        <p:nvSpPr>
-          <p:cNvPr id="3" name="TextBox 2"/>
-          <p:cNvSpPr txBox="1"/>
-          <p:nvPr/>
-        </p:nvSpPr>
-        <p:spPr>
-          <a:xfrm>
-            <a:off x="609600" y="914400"/>
-            <a:ext cx="7620000" cy="1569660"/>
-          </a:xfrm>
-          <a:prstGeom prst="rect">
-            <a:avLst/>
-          </a:prstGeom>
-          <a:noFill/>
-        </p:spPr>
-        <p:txBody>
-          <a:bodyPr wrap="square" rtlCol="0">
-            <a:spAutoFit/>
-          </a:bodyPr>
-          <a:lstStyle/>
-          <a:p>
-            <a:pPr algn="ctr"/>
-            <a:r>
-              <a:rPr lang="en-CA" sz="3200" dirty="0">
-                <a:solidFill>
-                  <a:schemeClr val="bg1"/>
-                </a:solidFill>
-              </a:rPr>
-              <a:t>While you were enjoying a relaxing week without classes, I was working hard, pondering the:</a:t>
-            </a:r>
-          </a:p>
-        </p:txBody>
-      </p:sp>
-      <p:sp>
-        <p:nvSpPr>
-          <p:cNvPr id="4" name="TextBox 3"/>
-          <p:cNvSpPr txBox="1"/>
-          <p:nvPr/>
-        </p:nvSpPr>
-        <p:spPr>
-          <a:xfrm>
-            <a:off x="838200" y="2971800"/>
-            <a:ext cx="7162800" cy="1754326"/>
-          </a:xfrm>
-          <a:prstGeom prst="rect">
-            <a:avLst/>
-          </a:prstGeom>
-          <a:noFill/>
-        </p:spPr>
-        <p:txBody>
-          <a:bodyPr wrap="square" rtlCol="0">
-            <a:spAutoFit/>
-          </a:bodyPr>
-          <a:lstStyle/>
-          <a:p>
-            <a:pPr algn="ctr"/>
-            <a:r>
-              <a:rPr lang="en-CA" sz="5400" dirty="0">
-                <a:solidFill>
-                  <a:schemeClr val="bg1"/>
-                </a:solidFill>
-              </a:rPr>
-              <a:t>Deep Questions of Data Visualization</a:t>
-            </a:r>
-          </a:p>
-        </p:txBody>
-      </p:sp>
       <p:pic>
         <p:nvPicPr>
-          <p:cNvPr id="6" name="Picture 5">
+          <p:cNvPr id="4" name="Picture 3" descr="A scuba diver swimming near coral reef&#10;&#10;Description automatically generated">
             <a:extLst>
               <a:ext uri="{FF2B5EF4-FFF2-40B4-BE49-F238E27FC236}">
-                <a16:creationId xmlns:a16="http://schemas.microsoft.com/office/drawing/2014/main" id="{8D4738BC-C316-C6E3-C8F7-330A787C2856}"/>
+                <a16:creationId xmlns:a16="http://schemas.microsoft.com/office/drawing/2014/main" id="{43461139-F544-0619-BDDB-E0CA6799DB54}"/>
               </a:ext>
             </a:extLst>
           </p:cNvPr>
@@ -8131,25 +10277,166 @@
           <p:nvPr/>
         </p:nvPicPr>
         <p:blipFill>
-          <a:blip r:embed="rId3"/>
+          <a:blip r:embed="rId2">
+            <a:extLst>
+              <a:ext uri="{28A0092B-C50C-407E-A947-70E740481C1C}">
+                <a14:useLocalDpi xmlns:a14="http://schemas.microsoft.com/office/drawing/2010/main" val="0"/>
+              </a:ext>
+            </a:extLst>
+          </a:blip>
           <a:stretch>
             <a:fillRect/>
           </a:stretch>
         </p:blipFill>
         <p:spPr>
           <a:xfrm>
-            <a:off x="762000" y="4347617"/>
-            <a:ext cx="1234547" cy="1585097"/>
+            <a:off x="472440" y="1938251"/>
+            <a:ext cx="8290560" cy="4663440"/>
           </a:xfrm>
           <a:prstGeom prst="rect">
             <a:avLst/>
           </a:prstGeom>
         </p:spPr>
       </p:pic>
+      <p:sp>
+        <p:nvSpPr>
+          <p:cNvPr id="6" name="TextBox 5">
+            <a:extLst>
+              <a:ext uri="{FF2B5EF4-FFF2-40B4-BE49-F238E27FC236}">
+                <a16:creationId xmlns:a16="http://schemas.microsoft.com/office/drawing/2014/main" id="{C1AD5815-FBD4-8770-B2DC-3134517D549C}"/>
+              </a:ext>
+            </a:extLst>
+          </p:cNvPr>
+          <p:cNvSpPr txBox="1"/>
+          <p:nvPr/>
+        </p:nvSpPr>
+        <p:spPr>
+          <a:xfrm>
+            <a:off x="474898" y="221768"/>
+            <a:ext cx="8288102" cy="1569660"/>
+          </a:xfrm>
+          <a:prstGeom prst="rect">
+            <a:avLst/>
+          </a:prstGeom>
+          <a:solidFill>
+            <a:schemeClr val="tx2">
+              <a:lumMod val="20000"/>
+              <a:lumOff val="80000"/>
+            </a:schemeClr>
+          </a:solidFill>
+        </p:spPr>
+        <p:txBody>
+          <a:bodyPr wrap="square">
+            <a:spAutoFit/>
+          </a:bodyPr>
+          <a:lstStyle/>
+          <a:p>
+            <a:pPr algn="ctr"/>
+            <a:r>
+              <a:rPr lang="en-CA" sz="3200" dirty="0"/>
+              <a:t>While you were enjoying a relaxing week without classes, I was working hard, pondering the:</a:t>
+            </a:r>
+          </a:p>
+        </p:txBody>
+      </p:sp>
+      <p:sp>
+        <p:nvSpPr>
+          <p:cNvPr id="7" name="Rectangle 6">
+            <a:extLst>
+              <a:ext uri="{FF2B5EF4-FFF2-40B4-BE49-F238E27FC236}">
+                <a16:creationId xmlns:a16="http://schemas.microsoft.com/office/drawing/2014/main" id="{3CB78289-0A23-330C-ADAE-9CA292B2DF3E}"/>
+              </a:ext>
+            </a:extLst>
+          </p:cNvPr>
+          <p:cNvSpPr/>
+          <p:nvPr/>
+        </p:nvSpPr>
+        <p:spPr>
+          <a:xfrm>
+            <a:off x="1371599" y="1979474"/>
+            <a:ext cx="6477001" cy="1938992"/>
+          </a:xfrm>
+          <a:prstGeom prst="rect">
+            <a:avLst/>
+          </a:prstGeom>
+          <a:noFill/>
+        </p:spPr>
+        <p:txBody>
+          <a:bodyPr wrap="square" lIns="91440" tIns="45720" rIns="91440" bIns="45720">
+            <a:spAutoFit/>
+          </a:bodyPr>
+          <a:lstStyle/>
+          <a:p>
+            <a:pPr algn="ctr"/>
+            <a:r>
+              <a:rPr lang="en-US" sz="6000" b="1" cap="none" spc="0" dirty="0">
+                <a:ln w="13462">
+                  <a:solidFill>
+                    <a:schemeClr val="bg1"/>
+                  </a:solidFill>
+                  <a:prstDash val="solid"/>
+                </a:ln>
+                <a:solidFill>
+                  <a:schemeClr val="tx1">
+                    <a:lumMod val="85000"/>
+                    <a:lumOff val="15000"/>
+                  </a:schemeClr>
+                </a:solidFill>
+                <a:effectLst>
+                  <a:outerShdw dist="38100" dir="2700000" algn="bl" rotWithShape="0">
+                    <a:schemeClr val="accent5"/>
+                  </a:outerShdw>
+                </a:effectLst>
+              </a:rPr>
+              <a:t>Deep questions of data visualization</a:t>
+            </a:r>
+          </a:p>
+        </p:txBody>
+      </p:sp>
+      <p:sp>
+        <p:nvSpPr>
+          <p:cNvPr id="3" name="TextBox 2">
+            <a:extLst>
+              <a:ext uri="{FF2B5EF4-FFF2-40B4-BE49-F238E27FC236}">
+                <a16:creationId xmlns:a16="http://schemas.microsoft.com/office/drawing/2014/main" id="{6ECD6215-1856-26D0-2726-A3D786556BED}"/>
+              </a:ext>
+            </a:extLst>
+          </p:cNvPr>
+          <p:cNvSpPr txBox="1"/>
+          <p:nvPr/>
+        </p:nvSpPr>
+        <p:spPr>
+          <a:xfrm>
+            <a:off x="1981200" y="4495800"/>
+            <a:ext cx="5562600" cy="954107"/>
+          </a:xfrm>
+          <a:prstGeom prst="rect">
+            <a:avLst/>
+          </a:prstGeom>
+          <a:noFill/>
+        </p:spPr>
+        <p:txBody>
+          <a:bodyPr wrap="square" rtlCol="0">
+            <a:spAutoFit/>
+          </a:bodyPr>
+          <a:lstStyle/>
+          <a:p>
+            <a:pPr algn="ctr"/>
+            <a:r>
+              <a:rPr lang="en-CA" sz="2800" b="1" dirty="0">
+                <a:solidFill>
+                  <a:schemeClr val="bg1"/>
+                </a:solidFill>
+              </a:rPr>
+              <a:t>Preference for graphic forms among marine animals</a:t>
+            </a:r>
+          </a:p>
+        </p:txBody>
+      </p:sp>
     </p:spTree>
     <p:extLst>
       <p:ext uri="{BB962C8B-B14F-4D97-AF65-F5344CB8AC3E}">
-        <p14:creationId xmlns:p14="http://schemas.microsoft.com/office/powerpoint/2010/main" val="2570832178"/>
+        <p14:creationId xmlns:p14="http://schemas.microsoft.com/office/powerpoint/2010/main" val="2435667889"/>
       </p:ext>
     </p:extLst>
   </p:cSld>
@@ -8178,6 +10465,187 @@
       </p:grpSpPr>
       <p:sp>
         <p:nvSpPr>
+          <p:cNvPr id="2" name="Slide Number Placeholder 1">
+            <a:extLst>
+              <a:ext uri="{FF2B5EF4-FFF2-40B4-BE49-F238E27FC236}">
+                <a16:creationId xmlns:a16="http://schemas.microsoft.com/office/drawing/2014/main" id="{C297824D-E3DF-F9BD-1C89-B20F3E3A5EE5}"/>
+              </a:ext>
+            </a:extLst>
+          </p:cNvPr>
+          <p:cNvSpPr>
+            <a:spLocks noGrp="1"/>
+          </p:cNvSpPr>
+          <p:nvPr>
+            <p:ph type="sldNum" sz="quarter" idx="12"/>
+          </p:nvPr>
+        </p:nvSpPr>
+        <p:spPr/>
+        <p:txBody>
+          <a:bodyPr/>
+          <a:lstStyle/>
+          <a:p>
+            <a:fld id="{621225AB-15B9-4C79-A121-04D1DC7E2307}" type="slidenum">
+              <a:rPr lang="en-US" smtClean="0"/>
+              <a:t>3</a:t>
+            </a:fld>
+            <a:endParaRPr lang="en-US"/>
+          </a:p>
+        </p:txBody>
+      </p:sp>
+      <p:pic>
+        <p:nvPicPr>
+          <p:cNvPr id="6" name="Picture 5">
+            <a:extLst>
+              <a:ext uri="{FF2B5EF4-FFF2-40B4-BE49-F238E27FC236}">
+                <a16:creationId xmlns:a16="http://schemas.microsoft.com/office/drawing/2014/main" id="{AF555746-D990-E0DF-FA80-2E65A374680B}"/>
+              </a:ext>
+            </a:extLst>
+          </p:cNvPr>
+          <p:cNvPicPr>
+            <a:picLocks noChangeAspect="1"/>
+          </p:cNvPicPr>
+          <p:nvPr/>
+        </p:nvPicPr>
+        <p:blipFill>
+          <a:blip r:embed="rId2">
+            <a:extLst>
+              <a:ext uri="{28A0092B-C50C-407E-A947-70E740481C1C}">
+                <a14:useLocalDpi xmlns:a14="http://schemas.microsoft.com/office/drawing/2010/main" val="0"/>
+              </a:ext>
+            </a:extLst>
+          </a:blip>
+          <a:stretch>
+            <a:fillRect/>
+          </a:stretch>
+        </p:blipFill>
+        <p:spPr>
+          <a:xfrm>
+            <a:off x="1157944" y="1391610"/>
+            <a:ext cx="6828112" cy="4999153"/>
+          </a:xfrm>
+          <a:prstGeom prst="rect">
+            <a:avLst/>
+          </a:prstGeom>
+        </p:spPr>
+      </p:pic>
+      <p:sp>
+        <p:nvSpPr>
+          <p:cNvPr id="8" name="TextBox 7">
+            <a:extLst>
+              <a:ext uri="{FF2B5EF4-FFF2-40B4-BE49-F238E27FC236}">
+                <a16:creationId xmlns:a16="http://schemas.microsoft.com/office/drawing/2014/main" id="{D11303E6-E0C3-962F-25BF-546D943275CD}"/>
+              </a:ext>
+            </a:extLst>
+          </p:cNvPr>
+          <p:cNvSpPr txBox="1"/>
+          <p:nvPr/>
+        </p:nvSpPr>
+        <p:spPr>
+          <a:xfrm>
+            <a:off x="1189898" y="304800"/>
+            <a:ext cx="6828111" cy="954107"/>
+          </a:xfrm>
+          <a:prstGeom prst="rect">
+            <a:avLst/>
+          </a:prstGeom>
+          <a:noFill/>
+        </p:spPr>
+        <p:txBody>
+          <a:bodyPr wrap="square">
+            <a:spAutoFit/>
+          </a:bodyPr>
+          <a:lstStyle/>
+          <a:p>
+            <a:r>
+              <a:rPr lang="en-CA" sz="2800" b="1" dirty="0"/>
+              <a:t>The Deep Question Research Institute</a:t>
+            </a:r>
+            <a:r>
+              <a:rPr lang="en-CA" sz="2800" dirty="0"/>
+              <a:t>, </a:t>
+            </a:r>
+          </a:p>
+          <a:p>
+            <a:r>
+              <a:rPr lang="en-CA" sz="2800" dirty="0"/>
+              <a:t>Hawksbill Resort, Antigua</a:t>
+            </a:r>
+          </a:p>
+        </p:txBody>
+      </p:sp>
+      <p:sp>
+        <p:nvSpPr>
+          <p:cNvPr id="9" name="TextBox 8">
+            <a:extLst>
+              <a:ext uri="{FF2B5EF4-FFF2-40B4-BE49-F238E27FC236}">
+                <a16:creationId xmlns:a16="http://schemas.microsoft.com/office/drawing/2014/main" id="{D065CCB7-F9E9-D943-D86F-6B1F7620EA30}"/>
+              </a:ext>
+            </a:extLst>
+          </p:cNvPr>
+          <p:cNvSpPr txBox="1"/>
+          <p:nvPr/>
+        </p:nvSpPr>
+        <p:spPr>
+          <a:xfrm>
+            <a:off x="1295400" y="1600200"/>
+            <a:ext cx="2514600" cy="923330"/>
+          </a:xfrm>
+          <a:prstGeom prst="rect">
+            <a:avLst/>
+          </a:prstGeom>
+          <a:solidFill>
+            <a:schemeClr val="accent3">
+              <a:lumMod val="20000"/>
+              <a:lumOff val="80000"/>
+              <a:alpha val="70000"/>
+            </a:schemeClr>
+          </a:solidFill>
+        </p:spPr>
+        <p:txBody>
+          <a:bodyPr wrap="square" rtlCol="0">
+            <a:spAutoFit/>
+          </a:bodyPr>
+          <a:lstStyle/>
+          <a:p>
+            <a:r>
+              <a:rPr lang="en-US" dirty="0"/>
+              <a:t>The first scientific study of graphical preference among marine animals!</a:t>
+            </a:r>
+          </a:p>
+        </p:txBody>
+      </p:sp>
+    </p:spTree>
+    <p:extLst>
+      <p:ext uri="{BB962C8B-B14F-4D97-AF65-F5344CB8AC3E}">
+        <p14:creationId xmlns:p14="http://schemas.microsoft.com/office/powerpoint/2010/main" val="4138712122"/>
+      </p:ext>
+    </p:extLst>
+  </p:cSld>
+  <p:clrMapOvr>
+    <a:masterClrMapping/>
+  </p:clrMapOvr>
+</p:sld>
+</file>
+
+<file path=ppt/slides/slide4.xml><?xml version="1.0" encoding="utf-8"?>
+<p:sld xmlns:a="http://schemas.openxmlformats.org/drawingml/2006/main" xmlns:r="http://schemas.openxmlformats.org/officeDocument/2006/relationships" xmlns:p="http://schemas.openxmlformats.org/presentationml/2006/main" show="0">
+  <p:cSld>
+    <p:spTree>
+      <p:nvGrpSpPr>
+        <p:cNvPr id="1" name=""/>
+        <p:cNvGrpSpPr/>
+        <p:nvPr/>
+      </p:nvGrpSpPr>
+      <p:grpSpPr>
+        <a:xfrm>
+          <a:off x="0" y="0"/>
+          <a:ext cx="0" cy="0"/>
+          <a:chOff x="0" y="0"/>
+          <a:chExt cx="0" cy="0"/>
+        </a:xfrm>
+      </p:grpSpPr>
+      <p:sp>
+        <p:nvSpPr>
           <p:cNvPr id="2" name="Slide Number Placeholder 1"/>
           <p:cNvSpPr>
             <a:spLocks noGrp="1"/>
@@ -8193,7 +10661,7 @@
           <a:p>
             <a:fld id="{621225AB-15B9-4C79-A121-04D1DC7E2307}" type="slidenum">
               <a:rPr lang="en-US" smtClean="0"/>
-              <a:t>3</a:t>
+              <a:t>4</a:t>
             </a:fld>
             <a:endParaRPr lang="en-US"/>
           </a:p>
@@ -8620,7 +11088,7 @@
 </p:sld>
 </file>
 
-<file path=ppt/slides/slide4.xml><?xml version="1.0" encoding="utf-8"?>
+<file path=ppt/slides/slide5.xml><?xml version="1.0" encoding="utf-8"?>
 <p:sld xmlns:a="http://schemas.openxmlformats.org/drawingml/2006/main" xmlns:r="http://schemas.openxmlformats.org/officeDocument/2006/relationships" xmlns:p="http://schemas.openxmlformats.org/presentationml/2006/main">
   <p:cSld>
     <p:spTree>
@@ -8654,7 +11122,7 @@
           <a:p>
             <a:fld id="{621225AB-15B9-4C79-A121-04D1DC7E2307}" type="slidenum">
               <a:rPr lang="en-US" smtClean="0"/>
-              <a:t>4</a:t>
+              <a:t>5</a:t>
             </a:fld>
             <a:endParaRPr lang="en-US"/>
           </a:p>
@@ -8710,12 +11178,17 @@
         <p:spPr>
           <a:xfrm>
             <a:off x="457200" y="668311"/>
-            <a:ext cx="4267200" cy="2708434"/>
+            <a:ext cx="4572000" cy="2708434"/>
           </a:xfrm>
           <a:prstGeom prst="rect">
             <a:avLst/>
           </a:prstGeom>
-          <a:noFill/>
+          <a:solidFill>
+            <a:schemeClr val="accent3">
+              <a:lumMod val="20000"/>
+              <a:lumOff val="80000"/>
+            </a:schemeClr>
+          </a:solidFill>
         </p:spPr>
         <p:txBody>
           <a:bodyPr wrap="square" rtlCol="0">
@@ -8725,7 +11198,7 @@
           <a:p>
             <a:r>
               <a:rPr lang="en-CA" sz="4000" dirty="0"/>
-              <a:t>Research team* aboard the </a:t>
+              <a:t>Research team aboard the </a:t>
             </a:r>
             <a:r>
               <a:rPr lang="en-CA" sz="4000" i="1" dirty="0"/>
@@ -8827,39 +11300,6 @@
           </a:p>
         </p:txBody>
       </p:sp>
-      <p:sp>
-        <p:nvSpPr>
-          <p:cNvPr id="5" name="TextBox 4"/>
-          <p:cNvSpPr txBox="1"/>
-          <p:nvPr/>
-        </p:nvSpPr>
-        <p:spPr>
-          <a:xfrm>
-            <a:off x="4419600" y="6096000"/>
-            <a:ext cx="3962400" cy="307777"/>
-          </a:xfrm>
-          <a:prstGeom prst="rect">
-            <a:avLst/>
-          </a:prstGeom>
-          <a:noFill/>
-        </p:spPr>
-        <p:txBody>
-          <a:bodyPr wrap="square" rtlCol="0">
-            <a:spAutoFit/>
-          </a:bodyPr>
-          <a:lstStyle/>
-          <a:p>
-            <a:r>
-              <a:rPr lang="en-US" sz="1400" baseline="30000" dirty="0"/>
-              <a:t>*</a:t>
-            </a:r>
-            <a:r>
-              <a:rPr lang="en-US" sz="1400" dirty="0"/>
-              <a:t> Thanks for technical assistance from Provo Divers</a:t>
-            </a:r>
-          </a:p>
-        </p:txBody>
-      </p:sp>
     </p:spTree>
     <p:extLst>
       <p:ext uri="{BB962C8B-B14F-4D97-AF65-F5344CB8AC3E}">
@@ -8873,7 +11313,7 @@
 </p:sld>
 </file>
 
-<file path=ppt/slides/slide5.xml><?xml version="1.0" encoding="utf-8"?>
+<file path=ppt/slides/slide6.xml><?xml version="1.0" encoding="utf-8"?>
 <p:sld xmlns:a="http://schemas.openxmlformats.org/drawingml/2006/main" xmlns:r="http://schemas.openxmlformats.org/officeDocument/2006/relationships" xmlns:p="http://schemas.openxmlformats.org/presentationml/2006/main">
   <p:cSld>
     <p:spTree>
@@ -8931,7 +11371,7 @@
           <a:p>
             <a:fld id="{621225AB-15B9-4C79-A121-04D1DC7E2307}" type="slidenum">
               <a:rPr lang="en-US" smtClean="0"/>
-              <a:t>5</a:t>
+              <a:t>6</a:t>
             </a:fld>
             <a:endParaRPr lang="en-US"/>
           </a:p>
@@ -9058,7 +11498,7 @@
         </p:nvSpPr>
         <p:spPr>
           <a:xfrm>
-            <a:off x="533400" y="2514600"/>
+            <a:off x="533400" y="2362200"/>
             <a:ext cx="7924800" cy="523220"/>
           </a:xfrm>
           <a:prstGeom prst="rect">
@@ -9155,8 +11595,8 @@
         </p:nvSpPr>
         <p:spPr>
           <a:xfrm>
-            <a:off x="6400800" y="3886200"/>
-            <a:ext cx="2238375" cy="830997"/>
+            <a:off x="1600200" y="3068980"/>
+            <a:ext cx="3048000" cy="461665"/>
           </a:xfrm>
           <a:prstGeom prst="rect">
             <a:avLst/>
@@ -9204,8 +11644,152 @@
         </p:blipFill>
         <p:spPr>
           <a:xfrm>
-            <a:off x="6524625" y="4539883"/>
-            <a:ext cx="1219200" cy="1219200"/>
+            <a:off x="6548284" y="3769062"/>
+            <a:ext cx="693737" cy="693737"/>
+          </a:xfrm>
+          <a:prstGeom prst="rect">
+            <a:avLst/>
+          </a:prstGeom>
+        </p:spPr>
+      </p:pic>
+      <p:sp>
+        <p:nvSpPr>
+          <p:cNvPr id="11" name="TextBox 10">
+            <a:extLst>
+              <a:ext uri="{FF2B5EF4-FFF2-40B4-BE49-F238E27FC236}">
+                <a16:creationId xmlns:a16="http://schemas.microsoft.com/office/drawing/2014/main" id="{231C71EA-C093-30A4-A4DC-860F82C8A210}"/>
+              </a:ext>
+            </a:extLst>
+          </p:cNvPr>
+          <p:cNvSpPr txBox="1"/>
+          <p:nvPr/>
+        </p:nvSpPr>
+        <p:spPr>
+          <a:xfrm>
+            <a:off x="6105832" y="3103860"/>
+            <a:ext cx="2362200" cy="461665"/>
+          </a:xfrm>
+          <a:prstGeom prst="rect">
+            <a:avLst/>
+          </a:prstGeom>
+          <a:noFill/>
+        </p:spPr>
+        <p:txBody>
+          <a:bodyPr wrap="square" rtlCol="0">
+            <a:spAutoFit/>
+          </a:bodyPr>
+          <a:lstStyle/>
+          <a:p>
+            <a:pPr algn="ctr"/>
+            <a:r>
+              <a:rPr lang="en-CA" sz="2400" dirty="0"/>
+              <a:t>Subjects</a:t>
+            </a:r>
+          </a:p>
+        </p:txBody>
+      </p:sp>
+      <p:pic>
+        <p:nvPicPr>
+          <p:cNvPr id="13" name="Picture 12" descr="A picture containing text&#10;&#10;Description automatically generated">
+            <a:extLst>
+              <a:ext uri="{FF2B5EF4-FFF2-40B4-BE49-F238E27FC236}">
+                <a16:creationId xmlns:a16="http://schemas.microsoft.com/office/drawing/2014/main" id="{CA9BC2A0-3D6E-F61F-B02C-12466DA4E74A}"/>
+              </a:ext>
+            </a:extLst>
+          </p:cNvPr>
+          <p:cNvPicPr>
+            <a:picLocks noChangeAspect="1"/>
+          </p:cNvPicPr>
+          <p:nvPr/>
+        </p:nvPicPr>
+        <p:blipFill>
+          <a:blip r:embed="rId4">
+            <a:extLst>
+              <a:ext uri="{28A0092B-C50C-407E-A947-70E740481C1C}">
+                <a14:useLocalDpi xmlns:a14="http://schemas.microsoft.com/office/drawing/2010/main" val="0"/>
+              </a:ext>
+            </a:extLst>
+          </a:blip>
+          <a:stretch>
+            <a:fillRect/>
+          </a:stretch>
+        </p:blipFill>
+        <p:spPr>
+          <a:xfrm>
+            <a:off x="7453475" y="4101479"/>
+            <a:ext cx="777518" cy="777518"/>
+          </a:xfrm>
+          <a:prstGeom prst="rect">
+            <a:avLst/>
+          </a:prstGeom>
+        </p:spPr>
+      </p:pic>
+      <p:pic>
+        <p:nvPicPr>
+          <p:cNvPr id="14" name="Picture 13" descr="A picture containing text&#10;&#10;Description automatically generated">
+            <a:extLst>
+              <a:ext uri="{FF2B5EF4-FFF2-40B4-BE49-F238E27FC236}">
+                <a16:creationId xmlns:a16="http://schemas.microsoft.com/office/drawing/2014/main" id="{26384553-C011-3363-BCB8-F2474166554A}"/>
+              </a:ext>
+            </a:extLst>
+          </p:cNvPr>
+          <p:cNvPicPr>
+            <a:picLocks noChangeAspect="1"/>
+          </p:cNvPicPr>
+          <p:nvPr/>
+        </p:nvPicPr>
+        <p:blipFill>
+          <a:blip r:embed="rId4">
+            <a:extLst>
+              <a:ext uri="{28A0092B-C50C-407E-A947-70E740481C1C}">
+                <a14:useLocalDpi xmlns:a14="http://schemas.microsoft.com/office/drawing/2010/main" val="0"/>
+              </a:ext>
+            </a:extLst>
+          </a:blip>
+          <a:stretch>
+            <a:fillRect/>
+          </a:stretch>
+        </p:blipFill>
+        <p:spPr>
+          <a:xfrm>
+            <a:off x="6548283" y="4765339"/>
+            <a:ext cx="693737" cy="693737"/>
+          </a:xfrm>
+          <a:prstGeom prst="rect">
+            <a:avLst/>
+          </a:prstGeom>
+        </p:spPr>
+      </p:pic>
+      <p:pic>
+        <p:nvPicPr>
+          <p:cNvPr id="15" name="Picture 14" descr="A picture containing text&#10;&#10;Description automatically generated">
+            <a:extLst>
+              <a:ext uri="{FF2B5EF4-FFF2-40B4-BE49-F238E27FC236}">
+                <a16:creationId xmlns:a16="http://schemas.microsoft.com/office/drawing/2014/main" id="{00C4B7A2-7C96-B62B-9D18-A5EE58FCB22C}"/>
+              </a:ext>
+            </a:extLst>
+          </p:cNvPr>
+          <p:cNvPicPr>
+            <a:picLocks noChangeAspect="1"/>
+          </p:cNvPicPr>
+          <p:nvPr/>
+        </p:nvPicPr>
+        <p:blipFill>
+          <a:blip r:embed="rId4">
+            <a:extLst>
+              <a:ext uri="{28A0092B-C50C-407E-A947-70E740481C1C}">
+                <a14:useLocalDpi xmlns:a14="http://schemas.microsoft.com/office/drawing/2010/main" val="0"/>
+              </a:ext>
+            </a:extLst>
+          </a:blip>
+          <a:stretch>
+            <a:fillRect/>
+          </a:stretch>
+        </p:blipFill>
+        <p:spPr>
+          <a:xfrm>
+            <a:off x="7537256" y="5062706"/>
+            <a:ext cx="693737" cy="693737"/>
           </a:xfrm>
           <a:prstGeom prst="rect">
             <a:avLst/>
@@ -9403,7 +11987,7 @@
 </p:sld>
 </file>
 
-<file path=ppt/slides/slide6.xml><?xml version="1.0" encoding="utf-8"?>
+<file path=ppt/slides/slide7.xml><?xml version="1.0" encoding="utf-8"?>
 <p:sld xmlns:a="http://schemas.openxmlformats.org/drawingml/2006/main" xmlns:r="http://schemas.openxmlformats.org/officeDocument/2006/relationships" xmlns:p="http://schemas.openxmlformats.org/presentationml/2006/main">
   <p:cSld>
     <p:spTree>
@@ -9461,7 +12045,7 @@
           <a:p>
             <a:fld id="{621225AB-15B9-4C79-A121-04D1DC7E2307}" type="slidenum">
               <a:rPr lang="en-US" smtClean="0"/>
-              <a:t>6</a:t>
+              <a:t>7</a:t>
             </a:fld>
             <a:endParaRPr lang="en-US"/>
           </a:p>
@@ -9530,8 +12114,8 @@
         </p:blipFill>
         <p:spPr>
           <a:xfrm>
-            <a:off x="2362200" y="1752600"/>
-            <a:ext cx="685714" cy="750476"/>
+            <a:off x="2362199" y="1752600"/>
+            <a:ext cx="1044365" cy="1143000"/>
           </a:xfrm>
           <a:prstGeom prst="rect">
             <a:avLst/>
@@ -9560,8 +12144,8 @@
         </p:blipFill>
         <p:spPr>
           <a:xfrm>
-            <a:off x="4572000" y="1752600"/>
-            <a:ext cx="734286" cy="745714"/>
+            <a:off x="4571999" y="1752599"/>
+            <a:ext cx="1044365" cy="1060619"/>
           </a:xfrm>
           <a:prstGeom prst="rect">
             <a:avLst/>
@@ -9644,7 +12228,7 @@
 </p:sld>
 </file>
 
-<file path=ppt/slides/slide7.xml><?xml version="1.0" encoding="utf-8"?>
+<file path=ppt/slides/slide8.xml><?xml version="1.0" encoding="utf-8"?>
 <p:sld xmlns:a="http://schemas.openxmlformats.org/drawingml/2006/main" xmlns:r="http://schemas.openxmlformats.org/officeDocument/2006/relationships" xmlns:p="http://schemas.openxmlformats.org/presentationml/2006/main">
   <p:cSld>
     <p:spTree>
@@ -9702,7 +12286,7 @@
           <a:p>
             <a:fld id="{621225AB-15B9-4C79-A121-04D1DC7E2307}" type="slidenum">
               <a:rPr lang="en-US" smtClean="0"/>
-              <a:t>7</a:t>
+              <a:t>8</a:t>
             </a:fld>
             <a:endParaRPr lang="en-US"/>
           </a:p>
@@ -10200,6 +12784,37 @@
                                   </p:childTnLst>
                                 </p:cTn>
                               </p:par>
+                              <p:par>
+                                <p:cTn id="9" presetID="1" presetClass="entr" presetSubtype="0" fill="hold" nodeType="withEffect">
+                                  <p:stCondLst>
+                                    <p:cond delay="0"/>
+                                  </p:stCondLst>
+                                  <p:childTnLst>
+                                    <p:set>
+                                      <p:cBhvr>
+                                        <p:cTn id="10" dur="1" fill="hold">
+                                          <p:stCondLst>
+                                            <p:cond delay="0"/>
+                                          </p:stCondLst>
+                                        </p:cTn>
+                                        <p:tgtEl>
+                                          <p:spTgt spid="10">
+                                            <p:txEl>
+                                              <p:pRg st="0" end="0"/>
+                                            </p:txEl>
+                                          </p:spTgt>
+                                        </p:tgtEl>
+                                        <p:attrNameLst>
+                                          <p:attrName>style.visibility</p:attrName>
+                                        </p:attrNameLst>
+                                      </p:cBhvr>
+                                      <p:to>
+                                        <p:strVal val="visible"/>
+                                      </p:to>
+                                    </p:set>
+                                  </p:childTnLst>
+                                </p:cTn>
+                              </p:par>
                             </p:childTnLst>
                           </p:cTn>
                         </p:par>
@@ -10231,7 +12846,7 @@
 </p:sld>
 </file>
 
-<file path=ppt/slides/slide8.xml><?xml version="1.0" encoding="utf-8"?>
+<file path=ppt/slides/slide9.xml><?xml version="1.0" encoding="utf-8"?>
 <p:sld xmlns:a="http://schemas.openxmlformats.org/drawingml/2006/main" xmlns:r="http://schemas.openxmlformats.org/officeDocument/2006/relationships" xmlns:p="http://schemas.openxmlformats.org/presentationml/2006/main">
   <p:cSld>
     <p:spTree>
@@ -10289,7 +12904,7 @@
           <a:p>
             <a:fld id="{621225AB-15B9-4C79-A121-04D1DC7E2307}" type="slidenum">
               <a:rPr lang="en-US" smtClean="0"/>
-              <a:t>8</a:t>
+              <a:t>9</a:t>
             </a:fld>
             <a:endParaRPr lang="en-US"/>
           </a:p>
@@ -10819,153 +13434,6 @@
       </p:par>
     </p:tnLst>
   </p:timing>
-</p:sld>
-</file>
-
-<file path=ppt/slides/slide9.xml><?xml version="1.0" encoding="utf-8"?>
-<p:sld xmlns:a="http://schemas.openxmlformats.org/drawingml/2006/main" xmlns:r="http://schemas.openxmlformats.org/officeDocument/2006/relationships" xmlns:p="http://schemas.openxmlformats.org/presentationml/2006/main">
-  <p:cSld>
-    <p:spTree>
-      <p:nvGrpSpPr>
-        <p:cNvPr id="1" name=""/>
-        <p:cNvGrpSpPr/>
-        <p:nvPr/>
-      </p:nvGrpSpPr>
-      <p:grpSpPr>
-        <a:xfrm>
-          <a:off x="0" y="0"/>
-          <a:ext cx="0" cy="0"/>
-          <a:chOff x="0" y="0"/>
-          <a:chExt cx="0" cy="0"/>
-        </a:xfrm>
-      </p:grpSpPr>
-      <p:sp>
-        <p:nvSpPr>
-          <p:cNvPr id="2" name="Title 1"/>
-          <p:cNvSpPr>
-            <a:spLocks noGrp="1"/>
-          </p:cNvSpPr>
-          <p:nvPr>
-            <p:ph type="title"/>
-          </p:nvPr>
-        </p:nvSpPr>
-        <p:spPr/>
-        <p:txBody>
-          <a:bodyPr>
-            <a:normAutofit fontScale="90000"/>
-          </a:bodyPr>
-          <a:lstStyle/>
-          <a:p>
-            <a:r>
-              <a:rPr lang="en-CA" dirty="0"/>
-              <a:t>Visualizing the results</a:t>
-            </a:r>
-          </a:p>
-        </p:txBody>
-      </p:sp>
-      <p:sp>
-        <p:nvSpPr>
-          <p:cNvPr id="3" name="Slide Number Placeholder 2"/>
-          <p:cNvSpPr>
-            <a:spLocks noGrp="1"/>
-          </p:cNvSpPr>
-          <p:nvPr>
-            <p:ph type="sldNum" sz="quarter" idx="12"/>
-          </p:nvPr>
-        </p:nvSpPr>
-        <p:spPr/>
-        <p:txBody>
-          <a:bodyPr/>
-          <a:lstStyle/>
-          <a:p>
-            <a:fld id="{621225AB-15B9-4C79-A121-04D1DC7E2307}" type="slidenum">
-              <a:rPr lang="en-US" smtClean="0"/>
-              <a:t>9</a:t>
-            </a:fld>
-            <a:endParaRPr lang="en-US"/>
-          </a:p>
-        </p:txBody>
-      </p:sp>
-      <p:pic>
-        <p:nvPicPr>
-          <p:cNvPr id="5122" name="Picture 2" descr="C:\Users\friendly\Pictures\2018-Provo\IMG_20180225_1445314-smaller.jpg"/>
-          <p:cNvPicPr>
-            <a:picLocks noChangeAspect="1" noChangeArrowheads="1"/>
-          </p:cNvPicPr>
-          <p:nvPr/>
-        </p:nvPicPr>
-        <p:blipFill>
-          <a:blip r:embed="rId2">
-            <a:extLst>
-              <a:ext uri="{28A0092B-C50C-407E-A947-70E740481C1C}">
-                <a14:useLocalDpi xmlns:a14="http://schemas.microsoft.com/office/drawing/2010/main" val="0"/>
-              </a:ext>
-            </a:extLst>
-          </a:blip>
-          <a:srcRect/>
-          <a:stretch>
-            <a:fillRect/>
-          </a:stretch>
-        </p:blipFill>
-        <p:spPr bwMode="auto">
-          <a:xfrm>
-            <a:off x="1066800" y="1981200"/>
-            <a:ext cx="6960870" cy="4640580"/>
-          </a:xfrm>
-          <a:prstGeom prst="rect">
-            <a:avLst/>
-          </a:prstGeom>
-          <a:noFill/>
-          <a:extLst>
-            <a:ext uri="{909E8E84-426E-40DD-AFC4-6F175D3DCCD1}">
-              <a14:hiddenFill xmlns:a14="http://schemas.microsoft.com/office/drawing/2010/main">
-                <a:solidFill>
-                  <a:srgbClr val="FFFFFF"/>
-                </a:solidFill>
-              </a14:hiddenFill>
-            </a:ext>
-          </a:extLst>
-        </p:spPr>
-      </p:pic>
-      <p:sp>
-        <p:nvSpPr>
-          <p:cNvPr id="4" name="TextBox 3"/>
-          <p:cNvSpPr txBox="1"/>
-          <p:nvPr/>
-        </p:nvSpPr>
-        <p:spPr>
-          <a:xfrm>
-            <a:off x="457200" y="1143000"/>
-            <a:ext cx="8229600" cy="461665"/>
-          </a:xfrm>
-          <a:prstGeom prst="rect">
-            <a:avLst/>
-          </a:prstGeom>
-          <a:noFill/>
-        </p:spPr>
-        <p:txBody>
-          <a:bodyPr wrap="square" rtlCol="0">
-            <a:spAutoFit/>
-          </a:bodyPr>
-          <a:lstStyle/>
-          <a:p>
-            <a:r>
-              <a:rPr lang="en-US" sz="2400" dirty="0"/>
-              <a:t>Successful visualizations require some time for reflection</a:t>
-            </a:r>
-          </a:p>
-        </p:txBody>
-      </p:sp>
-    </p:spTree>
-    <p:extLst>
-      <p:ext uri="{BB962C8B-B14F-4D97-AF65-F5344CB8AC3E}">
-        <p14:creationId xmlns:p14="http://schemas.microsoft.com/office/powerpoint/2010/main" val="415895312"/>
-      </p:ext>
-    </p:extLst>
-  </p:cSld>
-  <p:clrMapOvr>
-    <a:masterClrMapping/>
-  </p:clrMapOvr>
 </p:sld>
 </file>
 

</xml_diff>